<commit_message>
fix: type de structure en lecture seule
</commit_message>
<xml_diff>
--- a/docs/DeNoTa_Presentation.pptx
+++ b/docs/DeNoTa_Presentation.pptx
@@ -4,6 +4,9 @@
   <p:sldMasterIdLst>
     <p:sldMasterId id="2147483648" r:id="rId1"/>
   </p:sldMasterIdLst>
+  <p:notesMasterIdLst>
+    <p:notesMasterId r:id="rId12"/>
+  </p:notesMasterIdLst>
   <p:sldIdLst>
     <p:sldId id="256" r:id="rId2"/>
     <p:sldId id="257" r:id="rId3"/>
@@ -16,10 +19,7 @@
     <p:sldId id="264" r:id="rId10"/>
     <p:sldId id="265" r:id="rId11"/>
   </p:sldIdLst>
-  <p:notesMasterIdLst>
-    <p:notesMasterId r:id="rId12"/>
-  </p:notesMasterIdLst>
-  <p:sldSz cx="9144000" cy="5143500"/>
+  <p:sldSz cx="9144000" cy="5143500" type="screen16x9"/>
   <p:notesSz cx="5143500" cy="9144000"/>
   <p:defaultTextStyle>
     <a:lvl1pPr marL="0" algn="l" defTabSz="914400" rtl="0" eaLnBrk="1" latinLnBrk="0" hangingPunct="1">
@@ -113,6 +113,11 @@
       </a:defRPr>
     </a:lvl9pPr>
   </p:defaultTextStyle>
+  <p:extLst>
+    <p:ext uri="{EFAFB233-063F-42B5-8137-9DF3F51BA10A}">
+      <p15:sldGuideLst xmlns:p15="http://schemas.microsoft.com/office/powerpoint/2012/main"/>
+    </p:ext>
+  </p:extLst>
 </p:presentation>
 </file>
 
@@ -138,234 +143,10 @@
           <a:chExt cx="0" cy="0"/>
         </a:xfrm>
       </p:grpSpPr>
-      <p:sp>
-        <p:nvSpPr>
-          <p:cNvPr id="2" name="Header Placeholder 1"/>
-          <p:cNvSpPr>
-            <a:spLocks noGrp="1"/>
-          </p:cNvSpPr>
-          <p:nvPr>
-            <p:ph type="hdr" sz="quarter"/>
-          </p:nvPr>
-        </p:nvSpPr>
-        <p:spPr>
-          <a:xfrm>
-            <a:off x="0" y="0"/>
-            <a:ext cx="2971800" cy="458788"/>
-          </a:xfrm>
-          <a:prstGeom prst="rect">
-            <a:avLst/>
-          </a:prstGeom>
-        </p:spPr>
-        <p:txBody>
-          <a:bodyPr vert="horz" lIns="91440" tIns="45720" rIns="91440" bIns="45720" rtlCol="0"/>
-          <a:lstStyle>
-            <a:lvl1pPr algn="l">
-              <a:defRPr sz="1200"/>
-            </a:lvl1pPr>
-          </a:lstStyle>
-          <a:p>
-            <a:endParaRPr lang="en-US"/>
-          </a:p>
-        </p:txBody>
-      </p:sp>
-      <p:sp>
-        <p:nvSpPr>
-          <p:cNvPr id="3" name="Date Placeholder 2"/>
-          <p:cNvSpPr>
-            <a:spLocks noGrp="1"/>
-          </p:cNvSpPr>
-          <p:nvPr>
-            <p:ph type="dt" idx="1"/>
-          </p:nvPr>
-        </p:nvSpPr>
-        <p:spPr>
-          <a:xfrm>
-            <a:off x="3884613" y="0"/>
-            <a:ext cx="2971800" cy="458788"/>
-          </a:xfrm>
-          <a:prstGeom prst="rect">
-            <a:avLst/>
-          </a:prstGeom>
-        </p:spPr>
-        <p:txBody>
-          <a:bodyPr vert="horz" lIns="91440" tIns="45720" rIns="91440" bIns="45720" rtlCol="0"/>
-          <a:lstStyle>
-            <a:lvl1pPr algn="r">
-              <a:defRPr sz="1200"/>
-            </a:lvl1pPr>
-          </a:lstStyle>
-          <a:p>
-            <a:fld id="{5282F153-3F37-0F45-9E97-73ACFA13230C}" type="datetimeFigureOut">
-              <a:rPr lang="en-US"/>
-              <a:t>7/23/19</a:t>
-            </a:fld>
-            <a:endParaRPr lang="en-US"/>
-          </a:p>
-        </p:txBody>
-      </p:sp>
-      <p:sp>
-        <p:nvSpPr>
-          <p:cNvPr id="4" name="Slide Image Placeholder 3"/>
-          <p:cNvSpPr>
-            <a:spLocks noGrp="1" noRot="1" noChangeAspect="1"/>
-          </p:cNvSpPr>
-          <p:nvPr>
-            <p:ph type="sldImg" idx="2"/>
-          </p:nvPr>
-        </p:nvSpPr>
-        <p:spPr>
-          <a:xfrm>
-            <a:off x="685800" y="1143000"/>
-            <a:ext cx="5486400" cy="3086100"/>
-          </a:xfrm>
-          <a:prstGeom prst="rect">
-            <a:avLst/>
-          </a:prstGeom>
-          <a:noFill/>
-          <a:ln w="12700">
-            <a:solidFill>
-              <a:prstClr val="black"/>
-            </a:solidFill>
-          </a:ln>
-        </p:spPr>
-        <p:txBody>
-          <a:bodyPr vert="horz" lIns="91440" tIns="45720" rIns="91440" bIns="45720" rtlCol="0" anchor="ctr"/>
-          <a:lstStyle/>
-          <a:p>
-            <a:endParaRPr lang="en-US"/>
-          </a:p>
-        </p:txBody>
-      </p:sp>
-      <p:sp>
-        <p:nvSpPr>
-          <p:cNvPr id="5" name="Notes Placeholder 4"/>
-          <p:cNvSpPr>
-            <a:spLocks noGrp="1"/>
-          </p:cNvSpPr>
-          <p:nvPr>
-            <p:ph type="body" sz="quarter" idx="3"/>
-          </p:nvPr>
-        </p:nvSpPr>
-        <p:spPr>
-          <a:xfrm>
-            <a:off x="685800" y="4400550"/>
-            <a:ext cx="5486400" cy="3600450"/>
-          </a:xfrm>
-          <a:prstGeom prst="rect">
-            <a:avLst/>
-          </a:prstGeom>
-        </p:spPr>
-        <p:txBody>
-          <a:bodyPr vert="horz" lIns="91440" tIns="45720" rIns="91440" bIns="45720" rtlCol="0"/>
-          <a:lstStyle/>
-          <a:p>
-            <a:pPr lvl="0"/>
-            <a:r>
-              <a:rPr lang="en-US"/>
-              <a:t>Click to edit Master text styles</a:t>
-            </a:r>
-          </a:p>
-          <a:p>
-            <a:pPr lvl="1"/>
-            <a:r>
-              <a:rPr lang="en-US"/>
-              <a:t>Second level</a:t>
-            </a:r>
-          </a:p>
-          <a:p>
-            <a:pPr lvl="2"/>
-            <a:r>
-              <a:rPr lang="en-US"/>
-              <a:t>Third level</a:t>
-            </a:r>
-          </a:p>
-          <a:p>
-            <a:pPr lvl="3"/>
-            <a:r>
-              <a:rPr lang="en-US"/>
-              <a:t>Fourth level</a:t>
-            </a:r>
-          </a:p>
-          <a:p>
-            <a:pPr lvl="4"/>
-            <a:r>
-              <a:rPr lang="en-US"/>
-              <a:t>Fifth level</a:t>
-            </a:r>
-          </a:p>
-        </p:txBody>
-      </p:sp>
-      <p:sp>
-        <p:nvSpPr>
-          <p:cNvPr id="6" name="Footer Placeholder 5"/>
-          <p:cNvSpPr>
-            <a:spLocks noGrp="1"/>
-          </p:cNvSpPr>
-          <p:nvPr>
-            <p:ph type="ftr" sz="quarter" idx="4"/>
-          </p:nvPr>
-        </p:nvSpPr>
-        <p:spPr>
-          <a:xfrm>
-            <a:off x="0" y="8685213"/>
-            <a:ext cx="2971800" cy="458787"/>
-          </a:xfrm>
-          <a:prstGeom prst="rect">
-            <a:avLst/>
-          </a:prstGeom>
-        </p:spPr>
-        <p:txBody>
-          <a:bodyPr vert="horz" lIns="91440" tIns="45720" rIns="91440" bIns="45720" rtlCol="0" anchor="b"/>
-          <a:lstStyle>
-            <a:lvl1pPr algn="l">
-              <a:defRPr sz="1200"/>
-            </a:lvl1pPr>
-          </a:lstStyle>
-          <a:p>
-            <a:endParaRPr lang="en-US"/>
-          </a:p>
-        </p:txBody>
-      </p:sp>
-      <p:sp>
-        <p:nvSpPr>
-          <p:cNvPr id="7" name="Slide Number Placeholder 6"/>
-          <p:cNvSpPr>
-            <a:spLocks noGrp="1"/>
-          </p:cNvSpPr>
-          <p:nvPr>
-            <p:ph type="sldNum" sz="quarter" idx="5"/>
-          </p:nvPr>
-        </p:nvSpPr>
-        <p:spPr>
-          <a:xfrm>
-            <a:off x="3884613" y="8685213"/>
-            <a:ext cx="2971800" cy="458787"/>
-          </a:xfrm>
-          <a:prstGeom prst="rect">
-            <a:avLst/>
-          </a:prstGeom>
-        </p:spPr>
-        <p:txBody>
-          <a:bodyPr vert="horz" lIns="91440" tIns="45720" rIns="91440" bIns="45720" rtlCol="0" anchor="b"/>
-          <a:lstStyle>
-            <a:lvl1pPr algn="r">
-              <a:defRPr sz="1200"/>
-            </a:lvl1pPr>
-          </a:lstStyle>
-          <a:p>
-            <a:fld id="{CE5E9CC1-C706-0F49-92D6-E571CC5EEA8F}" type="slidenum">
-              <a:rPr lang="en-US"/>
-              <a:t>‹#›</a:t>
-            </a:fld>
-            <a:endParaRPr lang="en-US"/>
-          </a:p>
-        </p:txBody>
-      </p:sp>
     </p:spTree>
     <p:extLst>
       <p:ext uri="{BB962C8B-B14F-4D97-AF65-F5344CB8AC3E}">
-        <p14:creationId xmlns:p14="http://schemas.microsoft.com/office/powerpoint/2010/main" val="1024086991"/>
+        <p14:creationId xmlns:p14="http://schemas.microsoft.com/office/powerpoint/2010/main" val="1955658157"/>
       </p:ext>
     </p:extLst>
   </p:cSld>
@@ -509,10 +290,6 @@
           <a:bodyPr/>
           <a:lstStyle/>
           <a:p>
-            <a:r>
-              <a:rPr lang="en-US" dirty="0"/>
-              <a:t/>
-            </a:r>
             <a:endParaRPr lang="en-US" dirty="0"/>
           </a:p>
         </p:txBody>
@@ -597,10 +374,6 @@
           <a:bodyPr/>
           <a:lstStyle/>
           <a:p>
-            <a:r>
-              <a:rPr lang="en-US" dirty="0"/>
-              <a:t/>
-            </a:r>
             <a:endParaRPr lang="en-US" dirty="0"/>
           </a:p>
         </p:txBody>
@@ -685,10 +458,6 @@
           <a:bodyPr/>
           <a:lstStyle/>
           <a:p>
-            <a:r>
-              <a:rPr lang="en-US" dirty="0"/>
-              <a:t/>
-            </a:r>
             <a:endParaRPr lang="en-US" dirty="0"/>
           </a:p>
         </p:txBody>
@@ -773,10 +542,6 @@
           <a:bodyPr/>
           <a:lstStyle/>
           <a:p>
-            <a:r>
-              <a:rPr lang="en-US" dirty="0"/>
-              <a:t/>
-            </a:r>
             <a:endParaRPr lang="en-US" dirty="0"/>
           </a:p>
         </p:txBody>
@@ -861,10 +626,6 @@
           <a:bodyPr/>
           <a:lstStyle/>
           <a:p>
-            <a:r>
-              <a:rPr lang="en-US" dirty="0"/>
-              <a:t/>
-            </a:r>
             <a:endParaRPr lang="en-US" dirty="0"/>
           </a:p>
         </p:txBody>
@@ -949,10 +710,6 @@
           <a:bodyPr/>
           <a:lstStyle/>
           <a:p>
-            <a:r>
-              <a:rPr lang="en-US" dirty="0"/>
-              <a:t/>
-            </a:r>
             <a:endParaRPr lang="en-US" dirty="0"/>
           </a:p>
         </p:txBody>
@@ -1037,10 +794,6 @@
           <a:bodyPr/>
           <a:lstStyle/>
           <a:p>
-            <a:r>
-              <a:rPr lang="en-US" dirty="0"/>
-              <a:t/>
-            </a:r>
             <a:endParaRPr lang="en-US" dirty="0"/>
           </a:p>
         </p:txBody>
@@ -1125,10 +878,6 @@
           <a:bodyPr/>
           <a:lstStyle/>
           <a:p>
-            <a:r>
-              <a:rPr lang="en-US" dirty="0"/>
-              <a:t/>
-            </a:r>
             <a:endParaRPr lang="en-US" dirty="0"/>
           </a:p>
         </p:txBody>
@@ -1213,10 +962,6 @@
           <a:bodyPr/>
           <a:lstStyle/>
           <a:p>
-            <a:r>
-              <a:rPr lang="en-US" dirty="0"/>
-              <a:t/>
-            </a:r>
             <a:endParaRPr lang="en-US" dirty="0"/>
           </a:p>
         </p:txBody>
@@ -1301,10 +1046,6 @@
           <a:bodyPr/>
           <a:lstStyle/>
           <a:p>
-            <a:r>
-              <a:rPr lang="en-US" dirty="0"/>
-              <a:t/>
-            </a:r>
             <a:endParaRPr lang="en-US" dirty="0"/>
           </a:p>
         </p:txBody>
@@ -1378,6 +1119,11 @@
 <file path=ppt/slideMasters/slideMaster1.xml><?xml version="1.0" encoding="utf-8"?>
 <p:sldMaster xmlns:a="http://schemas.openxmlformats.org/drawingml/2006/main" xmlns:r="http://schemas.openxmlformats.org/officeDocument/2006/relationships" xmlns:p="http://schemas.openxmlformats.org/presentationml/2006/main">
   <p:cSld>
+    <p:bg>
+      <p:bgRef idx="1001">
+        <a:schemeClr val="bg1"/>
+      </p:bgRef>
+    </p:bg>
     <p:spTree>
       <p:nvGrpSpPr>
         <p:cNvPr id="1" name=""/>
@@ -1770,7 +1516,7 @@
           <a:bodyPr wrap="square" rtlCol="0" anchor="ctr"/>
           <a:lstStyle/>
           <a:p>
-            <a:pPr algn="ctr" indent="0" marL="0">
+            <a:pPr marL="0" indent="0" algn="ctr">
               <a:buNone/>
             </a:pPr>
             <a:r>
@@ -1806,7 +1552,7 @@
           <a:bodyPr wrap="square" lIns="0" tIns="0" rIns="0" bIns="0" rtlCol="0" anchor="ctr"/>
           <a:lstStyle/>
           <a:p>
-            <a:pPr indent="0" marL="0">
+            <a:pPr marL="0" indent="0">
               <a:buNone/>
             </a:pPr>
             <a:r>
@@ -1820,9 +1566,6 @@
               </a:rPr>
               <a:t>De</a:t>
             </a:r>
-            <a:pPr indent="0" marL="0">
-              <a:buNone/>
-            </a:pPr>
             <a:r>
               <a:rPr lang="en-US" sz="6400" b="1" dirty="0">
                 <a:solidFill>
@@ -1834,9 +1577,6 @@
               </a:rPr>
               <a:t>No</a:t>
             </a:r>
-            <a:pPr indent="0" marL="0">
-              <a:buNone/>
-            </a:pPr>
             <a:r>
               <a:rPr lang="en-US" sz="6400" b="1" dirty="0">
                 <a:solidFill>
@@ -1873,7 +1613,7 @@
           <a:bodyPr wrap="square" lIns="0" tIns="0" rIns="0" bIns="0" rtlCol="0" anchor="ctr"/>
           <a:lstStyle/>
           <a:p>
-            <a:pPr indent="0" marL="0">
+            <a:pPr marL="0" indent="0">
               <a:buNone/>
             </a:pPr>
             <a:r>
@@ -1912,7 +1652,7 @@
           <a:bodyPr wrap="square" lIns="0" tIns="0" rIns="0" bIns="0" rtlCol="0" anchor="ctr"/>
           <a:lstStyle/>
           <a:p>
-            <a:pPr indent="0" marL="0">
+            <a:pPr marL="0" indent="0">
               <a:buNone/>
             </a:pPr>
             <a:r>
@@ -1971,7 +1711,7 @@
           <a:bodyPr wrap="square" lIns="0" tIns="0" rIns="0" bIns="0" rtlCol="0" anchor="ctr"/>
           <a:lstStyle/>
           <a:p>
-            <a:pPr algn="ctr" indent="0" marL="0">
+            <a:pPr marL="0" indent="0" algn="ctr">
               <a:buNone/>
             </a:pPr>
             <a:r>
@@ -1983,7 +1723,40 @@
                 <a:ea typeface="Arial" pitchFamily="34" charset="-122"/>
                 <a:cs typeface="Arial" pitchFamily="34" charset="-120"/>
               </a:rPr>
-              <a:t>La plateforme qui révèle les talents sportifs d'Afrique de l'Ouest</a:t>
+              <a:t>La plateforme qui révèle les talents </a:t>
+            </a:r>
+            <a:r>
+              <a:rPr lang="en-US" sz="1400" dirty="0" err="1">
+                <a:solidFill>
+                  <a:srgbClr val="FFFFFF"/>
+                </a:solidFill>
+                <a:latin typeface="Arial" pitchFamily="34" charset="0"/>
+                <a:ea typeface="Arial" pitchFamily="34" charset="-122"/>
+                <a:cs typeface="Arial" pitchFamily="34" charset="-120"/>
+              </a:rPr>
+              <a:t>sportifs</a:t>
+            </a:r>
+            <a:r>
+              <a:rPr lang="en-US" sz="1400" dirty="0">
+                <a:solidFill>
+                  <a:srgbClr val="FFFFFF"/>
+                </a:solidFill>
+                <a:latin typeface="Arial" pitchFamily="34" charset="0"/>
+                <a:ea typeface="Arial" pitchFamily="34" charset="-122"/>
+                <a:cs typeface="Arial" pitchFamily="34" charset="-120"/>
+              </a:rPr>
+              <a:t> </a:t>
+            </a:r>
+            <a:r>
+              <a:rPr lang="en-US" sz="1400" dirty="0" err="1">
+                <a:solidFill>
+                  <a:srgbClr val="FFFFFF"/>
+                </a:solidFill>
+                <a:latin typeface="Arial" pitchFamily="34" charset="0"/>
+                <a:ea typeface="Arial" pitchFamily="34" charset="-122"/>
+                <a:cs typeface="Arial" pitchFamily="34" charset="-120"/>
+              </a:rPr>
+              <a:t>Ivoiriens</a:t>
             </a:r>
             <a:endParaRPr lang="en-US" sz="1400" dirty="0"/>
           </a:p>
@@ -2075,7 +1848,7 @@
           <a:bodyPr wrap="square" lIns="0" tIns="0" rIns="0" bIns="0" rtlCol="0" anchor="ctr"/>
           <a:lstStyle/>
           <a:p>
-            <a:pPr algn="ctr" indent="0" marL="0">
+            <a:pPr marL="0" indent="0" algn="ctr">
               <a:buNone/>
             </a:pPr>
             <a:r>
@@ -2111,7 +1884,7 @@
           <a:bodyPr wrap="square" lIns="0" tIns="0" rIns="0" bIns="0" rtlCol="0" anchor="ctr"/>
           <a:lstStyle/>
           <a:p>
-            <a:pPr algn="ctr" indent="0" marL="0">
+            <a:pPr marL="0" indent="0" algn="ctr">
               <a:buNone/>
             </a:pPr>
             <a:r>
@@ -2125,9 +1898,6 @@
               </a:rPr>
               <a:t>De</a:t>
             </a:r>
-            <a:pPr algn="ctr" indent="0" marL="0">
-              <a:buNone/>
-            </a:pPr>
             <a:r>
               <a:rPr lang="en-US" sz="5600" b="1" dirty="0">
                 <a:solidFill>
@@ -2139,9 +1909,6 @@
               </a:rPr>
               <a:t>No</a:t>
             </a:r>
-            <a:pPr algn="ctr" indent="0" marL="0">
-              <a:buNone/>
-            </a:pPr>
             <a:r>
               <a:rPr lang="en-US" sz="5600" b="1" dirty="0">
                 <a:solidFill>
@@ -2178,7 +1945,7 @@
           <a:bodyPr wrap="square" lIns="0" tIns="0" rIns="0" bIns="0" rtlCol="0" anchor="ctr"/>
           <a:lstStyle/>
           <a:p>
-            <a:pPr algn="ctr" indent="0" marL="0">
+            <a:pPr marL="0" indent="0" algn="ctr">
               <a:buNone/>
             </a:pPr>
             <a:r>
@@ -2217,9 +1984,20 @@
           <a:bodyPr wrap="square" lIns="0" tIns="0" rIns="0" bIns="0" rtlCol="0" anchor="ctr"/>
           <a:lstStyle/>
           <a:p>
-            <a:pPr algn="ctr" indent="0" marL="0">
-              <a:buNone/>
-            </a:pPr>
+            <a:pPr marL="0" indent="0" algn="ctr">
+              <a:buNone/>
+            </a:pPr>
+            <a:r>
+              <a:rPr lang="en-US" sz="1200" dirty="0" err="1">
+                <a:solidFill>
+                  <a:srgbClr val="A8D5B5"/>
+                </a:solidFill>
+                <a:latin typeface="Arial" pitchFamily="34" charset="0"/>
+                <a:ea typeface="Arial" pitchFamily="34" charset="-122"/>
+                <a:cs typeface="Arial" pitchFamily="34" charset="-120"/>
+              </a:rPr>
+              <a:t>www.Oyop-mt.com</a:t>
+            </a:r>
             <a:r>
               <a:rPr lang="en-US" sz="1200" dirty="0">
                 <a:solidFill>
@@ -2229,7 +2007,29 @@
                 <a:ea typeface="Arial" pitchFamily="34" charset="-122"/>
                 <a:cs typeface="Arial" pitchFamily="34" charset="-120"/>
               </a:rPr>
-              <a:t>denota.ci  ·  contact@denota.ci  ·  @DeNota_CI</a:t>
+              <a:t>·  </a:t>
+            </a:r>
+            <a:r>
+              <a:rPr lang="en-US" sz="1200" dirty="0" err="1">
+                <a:solidFill>
+                  <a:srgbClr val="A8D5B5"/>
+                </a:solidFill>
+                <a:latin typeface="Arial" pitchFamily="34" charset="0"/>
+                <a:ea typeface="Arial" pitchFamily="34" charset="-122"/>
+                <a:cs typeface="Arial" pitchFamily="34" charset="-120"/>
+              </a:rPr>
+              <a:t>contact@oyop-mt.com</a:t>
+            </a:r>
+            <a:r>
+              <a:rPr lang="en-US" sz="1200" dirty="0">
+                <a:solidFill>
+                  <a:srgbClr val="A8D5B5"/>
+                </a:solidFill>
+                <a:latin typeface="Arial" pitchFamily="34" charset="0"/>
+                <a:ea typeface="Arial" pitchFamily="34" charset="-122"/>
+                <a:cs typeface="Arial" pitchFamily="34" charset="-120"/>
+              </a:rPr>
+              <a:t>  ·  @DeNota_CI</a:t>
             </a:r>
             <a:endParaRPr lang="en-US" sz="1200" dirty="0"/>
           </a:p>
@@ -2321,7 +2121,7 @@
           <a:bodyPr wrap="square" lIns="0" tIns="0" rIns="0" bIns="0" rtlCol="0" anchor="ctr"/>
           <a:lstStyle/>
           <a:p>
-            <a:pPr indent="0" marL="0">
+            <a:pPr marL="0" indent="0">
               <a:buNone/>
             </a:pPr>
             <a:r>
@@ -2385,7 +2185,7 @@
           <a:bodyPr wrap="square" lIns="0" tIns="0" rIns="0" bIns="0" rtlCol="0" anchor="ctr"/>
           <a:lstStyle/>
           <a:p>
-            <a:pPr indent="0" marL="0">
+            <a:pPr marL="0" indent="0">
               <a:buNone/>
             </a:pPr>
             <a:r>
@@ -2424,7 +2224,7 @@
           <a:bodyPr wrap="square" lIns="0" tIns="0" rIns="0" bIns="0" rtlCol="0" anchor="ctr"/>
           <a:lstStyle/>
           <a:p>
-            <a:pPr indent="0" marL="0">
+            <a:pPr marL="0" indent="0">
               <a:buNone/>
             </a:pPr>
             <a:r>
@@ -2436,7 +2236,51 @@
                 <a:ea typeface="Arial" pitchFamily="34" charset="-122"/>
                 <a:cs typeface="Arial" pitchFamily="34" charset="-120"/>
               </a:rPr>
-              <a:t>• Des milliers de talents sportifs en Afrique de l'Ouest restent inconnus faute de visibilité</a:t>
+              <a:t>• Des milliers de talents sportifs </a:t>
+            </a:r>
+            <a:r>
+              <a:rPr lang="en-US" sz="1200" dirty="0" err="1">
+                <a:solidFill>
+                  <a:srgbClr val="2D3748"/>
+                </a:solidFill>
+                <a:latin typeface="Arial" pitchFamily="34" charset="0"/>
+                <a:ea typeface="Arial" pitchFamily="34" charset="-122"/>
+                <a:cs typeface="Arial" pitchFamily="34" charset="-120"/>
+              </a:rPr>
+              <a:t>en</a:t>
+            </a:r>
+            <a:r>
+              <a:rPr lang="en-US" sz="1200" dirty="0">
+                <a:solidFill>
+                  <a:srgbClr val="2D3748"/>
+                </a:solidFill>
+                <a:latin typeface="Arial" pitchFamily="34" charset="0"/>
+                <a:ea typeface="Arial" pitchFamily="34" charset="-122"/>
+                <a:cs typeface="Arial" pitchFamily="34" charset="-120"/>
+              </a:rPr>
+              <a:t> Côte d’Ivoire </a:t>
+            </a:r>
+            <a:r>
+              <a:rPr lang="en-US" sz="1200" dirty="0" err="1">
+                <a:solidFill>
+                  <a:srgbClr val="2D3748"/>
+                </a:solidFill>
+                <a:latin typeface="Arial" pitchFamily="34" charset="0"/>
+                <a:ea typeface="Arial" pitchFamily="34" charset="-122"/>
+                <a:cs typeface="Arial" pitchFamily="34" charset="-120"/>
+              </a:rPr>
+              <a:t>restent</a:t>
+            </a:r>
+            <a:r>
+              <a:rPr lang="en-US" sz="1200" dirty="0">
+                <a:solidFill>
+                  <a:srgbClr val="2D3748"/>
+                </a:solidFill>
+                <a:latin typeface="Arial" pitchFamily="34" charset="0"/>
+                <a:ea typeface="Arial" pitchFamily="34" charset="-122"/>
+                <a:cs typeface="Arial" pitchFamily="34" charset="-120"/>
+              </a:rPr>
+              <a:t> inconnus faute de visibilité</a:t>
             </a:r>
             <a:endParaRPr lang="en-US" sz="1200" dirty="0"/>
           </a:p>
@@ -2463,7 +2307,7 @@
           <a:bodyPr wrap="square" lIns="0" tIns="0" rIns="0" bIns="0" rtlCol="0" anchor="ctr"/>
           <a:lstStyle/>
           <a:p>
-            <a:pPr indent="0" marL="0">
+            <a:pPr marL="0" indent="0">
               <a:buNone/>
             </a:pPr>
             <a:r>
@@ -2475,7 +2319,95 @@
                 <a:ea typeface="Arial" pitchFamily="34" charset="-122"/>
                 <a:cs typeface="Arial" pitchFamily="34" charset="-120"/>
               </a:rPr>
-              <a:t>• Pas de plateforme digitale dédiée à la détection sportive en Côte d'Ivoire</a:t>
+              <a:t>• Pas de </a:t>
+            </a:r>
+            <a:r>
+              <a:rPr lang="en-US" sz="1200" dirty="0" err="1">
+                <a:solidFill>
+                  <a:srgbClr val="2D3748"/>
+                </a:solidFill>
+                <a:latin typeface="Arial" pitchFamily="34" charset="0"/>
+                <a:ea typeface="Arial" pitchFamily="34" charset="-122"/>
+                <a:cs typeface="Arial" pitchFamily="34" charset="-120"/>
+              </a:rPr>
+              <a:t>plateforme</a:t>
+            </a:r>
+            <a:r>
+              <a:rPr lang="en-US" sz="1200" dirty="0">
+                <a:solidFill>
+                  <a:srgbClr val="2D3748"/>
+                </a:solidFill>
+                <a:latin typeface="Arial" pitchFamily="34" charset="0"/>
+                <a:ea typeface="Arial" pitchFamily="34" charset="-122"/>
+                <a:cs typeface="Arial" pitchFamily="34" charset="-120"/>
+              </a:rPr>
+              <a:t> </a:t>
+            </a:r>
+            <a:r>
+              <a:rPr lang="en-US" sz="1200" dirty="0" err="1">
+                <a:solidFill>
+                  <a:srgbClr val="2D3748"/>
+                </a:solidFill>
+                <a:latin typeface="Arial" pitchFamily="34" charset="0"/>
+                <a:ea typeface="Arial" pitchFamily="34" charset="-122"/>
+                <a:cs typeface="Arial" pitchFamily="34" charset="-120"/>
+              </a:rPr>
+              <a:t>digitale</a:t>
+            </a:r>
+            <a:r>
+              <a:rPr lang="en-US" sz="1200" dirty="0">
+                <a:solidFill>
+                  <a:srgbClr val="2D3748"/>
+                </a:solidFill>
+                <a:latin typeface="Arial" pitchFamily="34" charset="0"/>
+                <a:ea typeface="Arial" pitchFamily="34" charset="-122"/>
+                <a:cs typeface="Arial" pitchFamily="34" charset="-120"/>
+              </a:rPr>
+              <a:t>, </a:t>
+            </a:r>
+            <a:r>
+              <a:rPr lang="en-US" sz="1200" dirty="0" err="1">
+                <a:solidFill>
+                  <a:srgbClr val="2D3748"/>
+                </a:solidFill>
+                <a:latin typeface="Arial" pitchFamily="34" charset="0"/>
+                <a:ea typeface="Arial" pitchFamily="34" charset="-122"/>
+                <a:cs typeface="Arial" pitchFamily="34" charset="-120"/>
+              </a:rPr>
+              <a:t>dédiée</a:t>
+            </a:r>
+            <a:r>
+              <a:rPr lang="en-US" sz="1200" dirty="0">
+                <a:solidFill>
+                  <a:srgbClr val="2D3748"/>
+                </a:solidFill>
+                <a:latin typeface="Arial" pitchFamily="34" charset="0"/>
+                <a:ea typeface="Arial" pitchFamily="34" charset="-122"/>
+                <a:cs typeface="Arial" pitchFamily="34" charset="-120"/>
+              </a:rPr>
+              <a:t> et </a:t>
+            </a:r>
+            <a:r>
+              <a:rPr lang="en-US" sz="1200" dirty="0" err="1">
+                <a:solidFill>
+                  <a:srgbClr val="2D3748"/>
+                </a:solidFill>
+                <a:latin typeface="Arial" pitchFamily="34" charset="0"/>
+                <a:ea typeface="Arial" pitchFamily="34" charset="-122"/>
+                <a:cs typeface="Arial" pitchFamily="34" charset="-120"/>
+              </a:rPr>
+              <a:t>connue</a:t>
+            </a:r>
+            <a:r>
+              <a:rPr lang="en-US" sz="1200" dirty="0">
+                <a:solidFill>
+                  <a:srgbClr val="2D3748"/>
+                </a:solidFill>
+                <a:latin typeface="Arial" pitchFamily="34" charset="0"/>
+                <a:ea typeface="Arial" pitchFamily="34" charset="-122"/>
+                <a:cs typeface="Arial" pitchFamily="34" charset="-120"/>
+              </a:rPr>
+              <a:t>, à la détection sportive en Côte d'Ivoire</a:t>
             </a:r>
             <a:endParaRPr lang="en-US" sz="1200" dirty="0"/>
           </a:p>
@@ -2502,7 +2434,7 @@
           <a:bodyPr wrap="square" lIns="0" tIns="0" rIns="0" bIns="0" rtlCol="0" anchor="ctr"/>
           <a:lstStyle/>
           <a:p>
-            <a:pPr indent="0" marL="0">
+            <a:pPr marL="0" indent="0">
               <a:buNone/>
             </a:pPr>
             <a:r>
@@ -2541,7 +2473,7 @@
           <a:bodyPr wrap="square" lIns="0" tIns="0" rIns="0" bIns="0" rtlCol="0" anchor="ctr"/>
           <a:lstStyle/>
           <a:p>
-            <a:pPr indent="0" marL="0">
+            <a:pPr marL="0" indent="0">
               <a:buNone/>
             </a:pPr>
             <a:r>
@@ -2605,7 +2537,7 @@
           <a:bodyPr wrap="square" lIns="0" tIns="0" rIns="0" bIns="0" rtlCol="0" anchor="ctr"/>
           <a:lstStyle/>
           <a:p>
-            <a:pPr indent="0" marL="0">
+            <a:pPr marL="0" indent="0">
               <a:buNone/>
             </a:pPr>
             <a:r>
@@ -2644,7 +2576,7 @@
           <a:bodyPr wrap="square" lIns="0" tIns="0" rIns="0" bIns="0" rtlCol="0" anchor="ctr"/>
           <a:lstStyle/>
           <a:p>
-            <a:pPr indent="0" marL="0">
+            <a:pPr marL="0" indent="0">
               <a:buNone/>
             </a:pPr>
             <a:r>
@@ -2683,7 +2615,7 @@
           <a:bodyPr wrap="square" lIns="0" tIns="0" rIns="0" bIns="0" rtlCol="0" anchor="ctr"/>
           <a:lstStyle/>
           <a:p>
-            <a:pPr indent="0" marL="0">
+            <a:pPr marL="0" indent="0">
               <a:buNone/>
             </a:pPr>
             <a:r>
@@ -2722,7 +2654,7 @@
           <a:bodyPr wrap="square" lIns="0" tIns="0" rIns="0" bIns="0" rtlCol="0" anchor="ctr"/>
           <a:lstStyle/>
           <a:p>
-            <a:pPr indent="0" marL="0">
+            <a:pPr marL="0" indent="0">
               <a:buNone/>
             </a:pPr>
             <a:r>
@@ -2761,7 +2693,7 @@
           <a:bodyPr wrap="square" lIns="0" tIns="0" rIns="0" bIns="0" rtlCol="0" anchor="ctr"/>
           <a:lstStyle/>
           <a:p>
-            <a:pPr indent="0" marL="0">
+            <a:pPr marL="0" indent="0">
               <a:buNone/>
             </a:pPr>
             <a:r>
@@ -2773,7 +2705,29 @@
                 <a:ea typeface="Arial" pitchFamily="34" charset="-122"/>
                 <a:cs typeface="Arial" pitchFamily="34" charset="-120"/>
               </a:rPr>
-              <a:t>• Aucun concurrent direct établi sur ce segment en Afrique francophone</a:t>
+              <a:t>• Peu de </a:t>
+            </a:r>
+            <a:r>
+              <a:rPr lang="en-US" sz="1200" dirty="0" err="1">
+                <a:solidFill>
+                  <a:srgbClr val="2D3748"/>
+                </a:solidFill>
+                <a:latin typeface="Arial" pitchFamily="34" charset="0"/>
+                <a:ea typeface="Arial" pitchFamily="34" charset="-122"/>
+                <a:cs typeface="Arial" pitchFamily="34" charset="-120"/>
+              </a:rPr>
+              <a:t>concurrents</a:t>
+            </a:r>
+            <a:r>
+              <a:rPr lang="en-US" sz="1200" dirty="0">
+                <a:solidFill>
+                  <a:srgbClr val="2D3748"/>
+                </a:solidFill>
+                <a:latin typeface="Arial" pitchFamily="34" charset="0"/>
+                <a:ea typeface="Arial" pitchFamily="34" charset="-122"/>
+                <a:cs typeface="Arial" pitchFamily="34" charset="-120"/>
+              </a:rPr>
+              <a:t> directs établi sur ce segment en Afrique francophone</a:t>
             </a:r>
             <a:endParaRPr lang="en-US" sz="1200" dirty="0"/>
           </a:p>
@@ -2865,7 +2819,7 @@
           <a:bodyPr wrap="square" lIns="0" tIns="0" rIns="0" bIns="0" rtlCol="0" anchor="ctr"/>
           <a:lstStyle/>
           <a:p>
-            <a:pPr indent="0" marL="0">
+            <a:pPr marL="0" indent="0">
               <a:buNone/>
             </a:pPr>
             <a:r>
@@ -2904,7 +2858,7 @@
           <a:bodyPr wrap="square" lIns="0" tIns="0" rIns="0" bIns="0" rtlCol="0" anchor="ctr"/>
           <a:lstStyle/>
           <a:p>
-            <a:pPr algn="ctr" indent="0" marL="0">
+            <a:pPr marL="0" indent="0" algn="ctr">
               <a:buNone/>
             </a:pPr>
             <a:r>
@@ -2930,7 +2884,7 @@
         </p:nvSpPr>
         <p:spPr>
           <a:xfrm>
-            <a:off x="365760" y="1371600"/>
+            <a:off x="208106" y="1371600"/>
             <a:ext cx="2011680" cy="3383280"/>
           </a:xfrm>
           <a:prstGeom prst="rect">
@@ -2955,7 +2909,7 @@
         </p:nvSpPr>
         <p:spPr>
           <a:xfrm>
-            <a:off x="365760" y="1508760"/>
+            <a:off x="208109" y="1508760"/>
             <a:ext cx="2011680" cy="640080"/>
           </a:xfrm>
           <a:prstGeom prst="rect">
@@ -2968,7 +2922,7 @@
           <a:bodyPr wrap="square" lIns="0" tIns="0" rIns="0" bIns="0" rtlCol="0" anchor="ctr"/>
           <a:lstStyle/>
           <a:p>
-            <a:pPr algn="ctr" indent="0" marL="0">
+            <a:pPr marL="0" indent="0" algn="ctr">
               <a:buNone/>
             </a:pPr>
             <a:r>
@@ -2991,7 +2945,7 @@
         </p:nvSpPr>
         <p:spPr>
           <a:xfrm>
-            <a:off x="457200" y="2240280"/>
+            <a:off x="299549" y="2240280"/>
             <a:ext cx="1828800" cy="411480"/>
           </a:xfrm>
           <a:prstGeom prst="rect">
@@ -3004,7 +2958,7 @@
           <a:bodyPr wrap="square" lIns="0" tIns="0" rIns="0" bIns="0" rtlCol="0" anchor="ctr"/>
           <a:lstStyle/>
           <a:p>
-            <a:pPr algn="ctr" indent="0" marL="0">
+            <a:pPr marL="0" indent="0" algn="ctr">
               <a:buNone/>
             </a:pPr>
             <a:r>
@@ -3030,7 +2984,7 @@
         </p:nvSpPr>
         <p:spPr>
           <a:xfrm>
-            <a:off x="822960" y="2651760"/>
+            <a:off x="665309" y="2651760"/>
             <a:ext cx="1097280" cy="27432"/>
           </a:xfrm>
           <a:prstGeom prst="rect">
@@ -3050,7 +3004,7 @@
         </p:nvSpPr>
         <p:spPr>
           <a:xfrm>
-            <a:off x="457200" y="2743200"/>
+            <a:off x="299549" y="2743200"/>
             <a:ext cx="1828800" cy="1645920"/>
           </a:xfrm>
           <a:prstGeom prst="rect">
@@ -3063,7 +3017,7 @@
           <a:bodyPr wrap="square" lIns="0" tIns="0" rIns="0" bIns="0" rtlCol="0" anchor="ctr"/>
           <a:lstStyle/>
           <a:p>
-            <a:pPr algn="ctr" indent="0" marL="0">
+            <a:pPr marL="0" indent="0" algn="ctr">
               <a:buNone/>
             </a:pPr>
             <a:r>
@@ -3080,7 +3034,7 @@
             <a:endParaRPr lang="en-US" sz="1100" dirty="0"/>
           </a:p>
           <a:p>
-            <a:pPr algn="ctr" indent="0" marL="0">
+            <a:pPr marL="0" indent="0" algn="ctr">
               <a:buNone/>
             </a:pPr>
             <a:r>
@@ -3106,7 +3060,7 @@
         </p:nvSpPr>
         <p:spPr>
           <a:xfrm>
-            <a:off x="2651760" y="1371600"/>
+            <a:off x="2494106" y="1371600"/>
             <a:ext cx="2011680" cy="3383280"/>
           </a:xfrm>
           <a:prstGeom prst="rect">
@@ -3131,7 +3085,7 @@
         </p:nvSpPr>
         <p:spPr>
           <a:xfrm>
-            <a:off x="2651760" y="1508760"/>
+            <a:off x="2494109" y="1508760"/>
             <a:ext cx="2011680" cy="640080"/>
           </a:xfrm>
           <a:prstGeom prst="rect">
@@ -3144,7 +3098,7 @@
           <a:bodyPr wrap="square" lIns="0" tIns="0" rIns="0" bIns="0" rtlCol="0" anchor="ctr"/>
           <a:lstStyle/>
           <a:p>
-            <a:pPr algn="ctr" indent="0" marL="0">
+            <a:pPr marL="0" indent="0" algn="ctr">
               <a:buNone/>
             </a:pPr>
             <a:r>
@@ -3167,7 +3121,7 @@
         </p:nvSpPr>
         <p:spPr>
           <a:xfrm>
-            <a:off x="2743200" y="2240280"/>
+            <a:off x="2585549" y="2240280"/>
             <a:ext cx="1828800" cy="411480"/>
           </a:xfrm>
           <a:prstGeom prst="rect">
@@ -3180,7 +3134,7 @@
           <a:bodyPr wrap="square" lIns="0" tIns="0" rIns="0" bIns="0" rtlCol="0" anchor="ctr"/>
           <a:lstStyle/>
           <a:p>
-            <a:pPr algn="ctr" indent="0" marL="0">
+            <a:pPr marL="0" indent="0" algn="ctr">
               <a:buNone/>
             </a:pPr>
             <a:r>
@@ -3206,7 +3160,7 @@
         </p:nvSpPr>
         <p:spPr>
           <a:xfrm>
-            <a:off x="3108960" y="2651760"/>
+            <a:off x="2951309" y="2651760"/>
             <a:ext cx="1097280" cy="27432"/>
           </a:xfrm>
           <a:prstGeom prst="rect">
@@ -3226,7 +3180,7 @@
         </p:nvSpPr>
         <p:spPr>
           <a:xfrm>
-            <a:off x="2743200" y="2743200"/>
+            <a:off x="2585549" y="2743200"/>
             <a:ext cx="1828800" cy="1645920"/>
           </a:xfrm>
           <a:prstGeom prst="rect">
@@ -3239,7 +3193,7 @@
           <a:bodyPr wrap="square" lIns="0" tIns="0" rIns="0" bIns="0" rtlCol="0" anchor="ctr"/>
           <a:lstStyle/>
           <a:p>
-            <a:pPr algn="ctr" indent="0" marL="0">
+            <a:pPr marL="0" indent="0" algn="ctr">
               <a:buNone/>
             </a:pPr>
             <a:r>
@@ -3256,7 +3210,7 @@
             <a:endParaRPr lang="en-US" sz="1100" dirty="0"/>
           </a:p>
           <a:p>
-            <a:pPr algn="ctr" indent="0" marL="0">
+            <a:pPr marL="0" indent="0" algn="ctr">
               <a:buNone/>
             </a:pPr>
             <a:r>
@@ -3282,7 +3236,7 @@
         </p:nvSpPr>
         <p:spPr>
           <a:xfrm>
-            <a:off x="4937760" y="1371600"/>
+            <a:off x="4706536" y="1371600"/>
             <a:ext cx="2011680" cy="3383280"/>
           </a:xfrm>
           <a:prstGeom prst="rect">
@@ -3307,7 +3261,7 @@
         </p:nvSpPr>
         <p:spPr>
           <a:xfrm>
-            <a:off x="4937760" y="1508760"/>
+            <a:off x="4706539" y="1508760"/>
             <a:ext cx="2011680" cy="640080"/>
           </a:xfrm>
           <a:prstGeom prst="rect">
@@ -3320,7 +3274,7 @@
           <a:bodyPr wrap="square" lIns="0" tIns="0" rIns="0" bIns="0" rtlCol="0" anchor="ctr"/>
           <a:lstStyle/>
           <a:p>
-            <a:pPr algn="ctr" indent="0" marL="0">
+            <a:pPr marL="0" indent="0" algn="ctr">
               <a:buNone/>
             </a:pPr>
             <a:r>
@@ -3343,7 +3297,7 @@
         </p:nvSpPr>
         <p:spPr>
           <a:xfrm>
-            <a:off x="5029200" y="2240280"/>
+            <a:off x="4797979" y="2240280"/>
             <a:ext cx="1828800" cy="411480"/>
           </a:xfrm>
           <a:prstGeom prst="rect">
@@ -3356,7 +3310,7 @@
           <a:bodyPr wrap="square" lIns="0" tIns="0" rIns="0" bIns="0" rtlCol="0" anchor="ctr"/>
           <a:lstStyle/>
           <a:p>
-            <a:pPr algn="ctr" indent="0" marL="0">
+            <a:pPr marL="0" indent="0" algn="ctr">
               <a:buNone/>
             </a:pPr>
             <a:r>
@@ -3382,7 +3336,7 @@
         </p:nvSpPr>
         <p:spPr>
           <a:xfrm>
-            <a:off x="5394960" y="2651760"/>
+            <a:off x="5237309" y="2651760"/>
             <a:ext cx="1097280" cy="27432"/>
           </a:xfrm>
           <a:prstGeom prst="rect">
@@ -3402,7 +3356,7 @@
         </p:nvSpPr>
         <p:spPr>
           <a:xfrm>
-            <a:off x="5029200" y="2743200"/>
+            <a:off x="4797979" y="2743200"/>
             <a:ext cx="1828800" cy="1645920"/>
           </a:xfrm>
           <a:prstGeom prst="rect">
@@ -3415,7 +3369,7 @@
           <a:bodyPr wrap="square" lIns="0" tIns="0" rIns="0" bIns="0" rtlCol="0" anchor="ctr"/>
           <a:lstStyle/>
           <a:p>
-            <a:pPr algn="ctr" indent="0" marL="0">
+            <a:pPr marL="0" indent="0" algn="ctr">
               <a:buNone/>
             </a:pPr>
             <a:r>
@@ -3432,7 +3386,7 @@
             <a:endParaRPr lang="en-US" sz="1100" dirty="0"/>
           </a:p>
           <a:p>
-            <a:pPr algn="ctr" indent="0" marL="0">
+            <a:pPr marL="0" indent="0" algn="ctr">
               <a:buNone/>
             </a:pPr>
             <a:r>
@@ -3458,7 +3412,7 @@
         </p:nvSpPr>
         <p:spPr>
           <a:xfrm>
-            <a:off x="7223760" y="1371600"/>
+            <a:off x="6950496" y="1371600"/>
             <a:ext cx="2011680" cy="3383280"/>
           </a:xfrm>
           <a:prstGeom prst="rect">
@@ -3483,7 +3437,7 @@
         </p:nvSpPr>
         <p:spPr>
           <a:xfrm>
-            <a:off x="7223760" y="1508760"/>
+            <a:off x="6950499" y="1508760"/>
             <a:ext cx="2011680" cy="640080"/>
           </a:xfrm>
           <a:prstGeom prst="rect">
@@ -3496,7 +3450,7 @@
           <a:bodyPr wrap="square" lIns="0" tIns="0" rIns="0" bIns="0" rtlCol="0" anchor="ctr"/>
           <a:lstStyle/>
           <a:p>
-            <a:pPr algn="ctr" indent="0" marL="0">
+            <a:pPr marL="0" indent="0" algn="ctr">
               <a:buNone/>
             </a:pPr>
             <a:r>
@@ -3519,7 +3473,7 @@
         </p:nvSpPr>
         <p:spPr>
           <a:xfrm>
-            <a:off x="7315200" y="2240280"/>
+            <a:off x="7041939" y="2240280"/>
             <a:ext cx="1828800" cy="411480"/>
           </a:xfrm>
           <a:prstGeom prst="rect">
@@ -3532,7 +3486,7 @@
           <a:bodyPr wrap="square" lIns="0" tIns="0" rIns="0" bIns="0" rtlCol="0" anchor="ctr"/>
           <a:lstStyle/>
           <a:p>
-            <a:pPr algn="ctr" indent="0" marL="0">
+            <a:pPr marL="0" indent="0" algn="ctr">
               <a:buNone/>
             </a:pPr>
             <a:r>
@@ -3558,7 +3512,7 @@
         </p:nvSpPr>
         <p:spPr>
           <a:xfrm>
-            <a:off x="7680960" y="2651760"/>
+            <a:off x="7523309" y="2651760"/>
             <a:ext cx="1097280" cy="27432"/>
           </a:xfrm>
           <a:prstGeom prst="rect">
@@ -3578,7 +3532,7 @@
         </p:nvSpPr>
         <p:spPr>
           <a:xfrm>
-            <a:off x="7315200" y="2743200"/>
+            <a:off x="7041939" y="2743200"/>
             <a:ext cx="1828800" cy="1645920"/>
           </a:xfrm>
           <a:prstGeom prst="rect">
@@ -3591,7 +3545,7 @@
           <a:bodyPr wrap="square" lIns="0" tIns="0" rIns="0" bIns="0" rtlCol="0" anchor="ctr"/>
           <a:lstStyle/>
           <a:p>
-            <a:pPr algn="ctr" indent="0" marL="0">
+            <a:pPr marL="0" indent="0" algn="ctr">
               <a:buNone/>
             </a:pPr>
             <a:r>
@@ -3608,7 +3562,7 @@
             <a:endParaRPr lang="en-US" sz="1100" dirty="0"/>
           </a:p>
           <a:p>
-            <a:pPr algn="ctr" indent="0" marL="0">
+            <a:pPr marL="0" indent="0" algn="ctr">
               <a:buNone/>
             </a:pPr>
             <a:r>
@@ -3712,7 +3666,7 @@
           <a:bodyPr wrap="square" lIns="0" tIns="0" rIns="0" bIns="0" rtlCol="0" anchor="ctr"/>
           <a:lstStyle/>
           <a:p>
-            <a:pPr indent="0" marL="0">
+            <a:pPr marL="0" indent="0">
               <a:buNone/>
             </a:pPr>
             <a:r>
@@ -3776,7 +3730,7 @@
           <a:bodyPr wrap="square" lIns="0" tIns="0" rIns="0" bIns="0" rtlCol="0" anchor="ctr"/>
           <a:lstStyle/>
           <a:p>
-            <a:pPr indent="0" marL="0">
+            <a:pPr marL="0" indent="0">
               <a:buNone/>
             </a:pPr>
             <a:r>
@@ -3815,7 +3769,7 @@
           <a:bodyPr wrap="square" lIns="0" tIns="0" rIns="0" bIns="0" rtlCol="0" anchor="ctr"/>
           <a:lstStyle/>
           <a:p>
-            <a:pPr indent="0" marL="0">
+            <a:pPr marL="0" indent="0">
               <a:buNone/>
             </a:pPr>
             <a:r>
@@ -3879,7 +3833,7 @@
           <a:bodyPr wrap="square" lIns="0" tIns="0" rIns="0" bIns="0" rtlCol="0" anchor="ctr"/>
           <a:lstStyle/>
           <a:p>
-            <a:pPr indent="0" marL="0">
+            <a:pPr marL="0" indent="0">
               <a:buNone/>
             </a:pPr>
             <a:r>
@@ -3918,7 +3872,7 @@
           <a:bodyPr wrap="square" lIns="0" tIns="0" rIns="0" bIns="0" rtlCol="0" anchor="ctr"/>
           <a:lstStyle/>
           <a:p>
-            <a:pPr indent="0" marL="0">
+            <a:pPr marL="0" indent="0">
               <a:buNone/>
             </a:pPr>
             <a:r>
@@ -3982,7 +3936,7 @@
           <a:bodyPr wrap="square" lIns="0" tIns="0" rIns="0" bIns="0" rtlCol="0" anchor="ctr"/>
           <a:lstStyle/>
           <a:p>
-            <a:pPr indent="0" marL="0">
+            <a:pPr marL="0" indent="0">
               <a:buNone/>
             </a:pPr>
             <a:r>
@@ -4021,7 +3975,7 @@
           <a:bodyPr wrap="square" lIns="0" tIns="0" rIns="0" bIns="0" rtlCol="0" anchor="ctr"/>
           <a:lstStyle/>
           <a:p>
-            <a:pPr indent="0" marL="0">
+            <a:pPr marL="0" indent="0">
               <a:buNone/>
             </a:pPr>
             <a:r>
@@ -4085,7 +4039,7 @@
           <a:bodyPr wrap="square" lIns="0" tIns="0" rIns="0" bIns="0" rtlCol="0" anchor="ctr"/>
           <a:lstStyle/>
           <a:p>
-            <a:pPr indent="0" marL="0">
+            <a:pPr marL="0" indent="0">
               <a:buNone/>
             </a:pPr>
             <a:r>
@@ -4124,7 +4078,7 @@
           <a:bodyPr wrap="square" lIns="0" tIns="0" rIns="0" bIns="0" rtlCol="0" anchor="ctr"/>
           <a:lstStyle/>
           <a:p>
-            <a:pPr indent="0" marL="0">
+            <a:pPr marL="0" indent="0">
               <a:buNone/>
             </a:pPr>
             <a:r>
@@ -4188,7 +4142,7 @@
           <a:bodyPr wrap="square" lIns="0" tIns="0" rIns="0" bIns="0" rtlCol="0" anchor="ctr"/>
           <a:lstStyle/>
           <a:p>
-            <a:pPr indent="0" marL="0">
+            <a:pPr marL="0" indent="0">
               <a:buNone/>
             </a:pPr>
             <a:r>
@@ -4227,7 +4181,7 @@
           <a:bodyPr wrap="square" lIns="0" tIns="0" rIns="0" bIns="0" rtlCol="0" anchor="ctr"/>
           <a:lstStyle/>
           <a:p>
-            <a:pPr indent="0" marL="0">
+            <a:pPr marL="0" indent="0">
               <a:buNone/>
             </a:pPr>
             <a:r>
@@ -4291,7 +4245,7 @@
           <a:bodyPr wrap="square" lIns="0" tIns="0" rIns="0" bIns="0" rtlCol="0" anchor="ctr"/>
           <a:lstStyle/>
           <a:p>
-            <a:pPr indent="0" marL="0">
+            <a:pPr marL="0" indent="0">
               <a:buNone/>
             </a:pPr>
             <a:r>
@@ -4330,7 +4284,7 @@
           <a:bodyPr wrap="square" lIns="0" tIns="0" rIns="0" bIns="0" rtlCol="0" anchor="ctr"/>
           <a:lstStyle/>
           <a:p>
-            <a:pPr indent="0" marL="0">
+            <a:pPr marL="0" indent="0">
               <a:buNone/>
             </a:pPr>
             <a:r>
@@ -4342,7 +4296,51 @@
                 <a:ea typeface="Arial" pitchFamily="34" charset="-122"/>
                 <a:cs typeface="Arial" pitchFamily="34" charset="-120"/>
               </a:rPr>
-              <a:t>Diffusion en direct de matchs et entraînements avec chat interactif en temps réel</a:t>
+              <a:t>Diffusion en direct de matchs et entraînements avec chat interactif en temps reel (</a:t>
+            </a:r>
+            <a:r>
+              <a:rPr lang="en-US" sz="1050" dirty="0" err="1">
+                <a:solidFill>
+                  <a:srgbClr val="2D3748"/>
+                </a:solidFill>
+                <a:latin typeface="Arial" pitchFamily="34" charset="0"/>
+                <a:ea typeface="Arial" pitchFamily="34" charset="-122"/>
+                <a:cs typeface="Arial" pitchFamily="34" charset="-120"/>
+              </a:rPr>
+              <a:t>projet</a:t>
+            </a:r>
+            <a:r>
+              <a:rPr lang="en-US" sz="1050" dirty="0">
+                <a:solidFill>
+                  <a:srgbClr val="2D3748"/>
+                </a:solidFill>
+                <a:latin typeface="Arial" pitchFamily="34" charset="0"/>
+                <a:ea typeface="Arial" pitchFamily="34" charset="-122"/>
+                <a:cs typeface="Arial" pitchFamily="34" charset="-120"/>
+              </a:rPr>
+              <a:t> à long </a:t>
+            </a:r>
+            <a:r>
+              <a:rPr lang="en-US" sz="1050" dirty="0" err="1">
+                <a:solidFill>
+                  <a:srgbClr val="2D3748"/>
+                </a:solidFill>
+                <a:latin typeface="Arial" pitchFamily="34" charset="0"/>
+                <a:ea typeface="Arial" pitchFamily="34" charset="-122"/>
+                <a:cs typeface="Arial" pitchFamily="34" charset="-120"/>
+              </a:rPr>
+              <a:t>terme</a:t>
+            </a:r>
+            <a:r>
+              <a:rPr lang="en-US" sz="1050" dirty="0">
+                <a:solidFill>
+                  <a:srgbClr val="2D3748"/>
+                </a:solidFill>
+                <a:latin typeface="Arial" pitchFamily="34" charset="0"/>
+                <a:ea typeface="Arial" pitchFamily="34" charset="-122"/>
+                <a:cs typeface="Arial" pitchFamily="34" charset="-120"/>
+              </a:rPr>
+              <a:t>)</a:t>
             </a:r>
             <a:endParaRPr lang="en-US" sz="1050" dirty="0"/>
           </a:p>
@@ -4434,7 +4432,7 @@
           <a:bodyPr wrap="square" lIns="0" tIns="0" rIns="0" bIns="0" rtlCol="0" anchor="ctr"/>
           <a:lstStyle/>
           <a:p>
-            <a:pPr indent="0" marL="0">
+            <a:pPr marL="0" indent="0">
               <a:buNone/>
             </a:pPr>
             <a:r>
@@ -4498,7 +4496,7 @@
           <a:bodyPr wrap="square" lIns="0" tIns="0" rIns="0" bIns="0" rtlCol="0" anchor="ctr"/>
           <a:lstStyle/>
           <a:p>
-            <a:pPr algn="ctr" indent="0" marL="0">
+            <a:pPr marL="0" indent="0" algn="ctr">
               <a:buNone/>
             </a:pPr>
             <a:r>
@@ -4534,7 +4532,7 @@
           <a:bodyPr wrap="square" lIns="0" tIns="0" rIns="0" bIns="0" rtlCol="0" anchor="ctr"/>
           <a:lstStyle/>
           <a:p>
-            <a:pPr algn="ctr" indent="0" marL="0">
+            <a:pPr marL="0" indent="0" algn="ctr">
               <a:buNone/>
             </a:pPr>
             <a:r>
@@ -4593,7 +4591,7 @@
           <a:bodyPr wrap="square" lIns="0" tIns="0" rIns="0" bIns="0" rtlCol="0" anchor="ctr"/>
           <a:lstStyle/>
           <a:p>
-            <a:pPr algn="ctr" indent="0" marL="0">
+            <a:pPr marL="0" indent="0" algn="ctr">
               <a:buNone/>
             </a:pPr>
             <a:r>
@@ -4610,7 +4608,7 @@
             <a:endParaRPr lang="en-US" sz="1050" dirty="0"/>
           </a:p>
           <a:p>
-            <a:pPr algn="ctr" indent="0" marL="0">
+            <a:pPr marL="0" indent="0" algn="ctr">
               <a:buNone/>
             </a:pPr>
             <a:r>
@@ -4627,7 +4625,7 @@
             <a:endParaRPr lang="en-US" sz="1050" dirty="0"/>
           </a:p>
           <a:p>
-            <a:pPr algn="ctr" indent="0" marL="0">
+            <a:pPr marL="0" indent="0" algn="ctr">
               <a:buNone/>
             </a:pPr>
             <a:r>
@@ -4691,7 +4689,7 @@
           <a:bodyPr wrap="square" lIns="0" tIns="0" rIns="0" bIns="0" rtlCol="0" anchor="ctr"/>
           <a:lstStyle/>
           <a:p>
-            <a:pPr algn="ctr" indent="0" marL="0">
+            <a:pPr marL="0" indent="0" algn="ctr">
               <a:buNone/>
             </a:pPr>
             <a:r>
@@ -4727,7 +4725,7 @@
           <a:bodyPr wrap="square" lIns="0" tIns="0" rIns="0" bIns="0" rtlCol="0" anchor="ctr"/>
           <a:lstStyle/>
           <a:p>
-            <a:pPr algn="ctr" indent="0" marL="0">
+            <a:pPr marL="0" indent="0" algn="ctr">
               <a:buNone/>
             </a:pPr>
             <a:r>
@@ -4786,7 +4784,7 @@
           <a:bodyPr wrap="square" lIns="0" tIns="0" rIns="0" bIns="0" rtlCol="0" anchor="ctr"/>
           <a:lstStyle/>
           <a:p>
-            <a:pPr algn="ctr" indent="0" marL="0">
+            <a:pPr marL="0" indent="0" algn="ctr">
               <a:buNone/>
             </a:pPr>
             <a:r>
@@ -4803,7 +4801,7 @@
             <a:endParaRPr lang="en-US" sz="1050" dirty="0"/>
           </a:p>
           <a:p>
-            <a:pPr algn="ctr" indent="0" marL="0">
+            <a:pPr marL="0" indent="0" algn="ctr">
               <a:buNone/>
             </a:pPr>
             <a:r>
@@ -4820,7 +4818,7 @@
             <a:endParaRPr lang="en-US" sz="1050" dirty="0"/>
           </a:p>
           <a:p>
-            <a:pPr algn="ctr" indent="0" marL="0">
+            <a:pPr marL="0" indent="0" algn="ctr">
               <a:buNone/>
             </a:pPr>
             <a:r>
@@ -4884,7 +4882,7 @@
           <a:bodyPr wrap="square" lIns="0" tIns="0" rIns="0" bIns="0" rtlCol="0" anchor="ctr"/>
           <a:lstStyle/>
           <a:p>
-            <a:pPr algn="ctr" indent="0" marL="0">
+            <a:pPr marL="0" indent="0" algn="ctr">
               <a:buNone/>
             </a:pPr>
             <a:r>
@@ -4920,7 +4918,7 @@
           <a:bodyPr wrap="square" lIns="0" tIns="0" rIns="0" bIns="0" rtlCol="0" anchor="ctr"/>
           <a:lstStyle/>
           <a:p>
-            <a:pPr algn="ctr" indent="0" marL="0">
+            <a:pPr marL="0" indent="0" algn="ctr">
               <a:buNone/>
             </a:pPr>
             <a:r>
@@ -4979,7 +4977,7 @@
           <a:bodyPr wrap="square" lIns="0" tIns="0" rIns="0" bIns="0" rtlCol="0" anchor="ctr"/>
           <a:lstStyle/>
           <a:p>
-            <a:pPr algn="ctr" indent="0" marL="0">
+            <a:pPr marL="0" indent="0" algn="ctr">
               <a:buNone/>
             </a:pPr>
             <a:r>
@@ -4996,7 +4994,7 @@
             <a:endParaRPr lang="en-US" sz="1050" dirty="0"/>
           </a:p>
           <a:p>
-            <a:pPr algn="ctr" indent="0" marL="0">
+            <a:pPr marL="0" indent="0" algn="ctr">
               <a:buNone/>
             </a:pPr>
             <a:r>
@@ -5013,7 +5011,7 @@
             <a:endParaRPr lang="en-US" sz="1050" dirty="0"/>
           </a:p>
           <a:p>
-            <a:pPr algn="ctr" indent="0" marL="0">
+            <a:pPr marL="0" indent="0" algn="ctr">
               <a:buNone/>
             </a:pPr>
             <a:r>
@@ -5077,7 +5075,7 @@
           <a:bodyPr wrap="square" lIns="0" tIns="0" rIns="0" bIns="0" rtlCol="0" anchor="ctr"/>
           <a:lstStyle/>
           <a:p>
-            <a:pPr algn="ctr" indent="0" marL="0">
+            <a:pPr marL="0" indent="0" algn="ctr">
               <a:buNone/>
             </a:pPr>
             <a:r>
@@ -5113,7 +5111,7 @@
           <a:bodyPr wrap="square" lIns="0" tIns="0" rIns="0" bIns="0" rtlCol="0" anchor="ctr"/>
           <a:lstStyle/>
           <a:p>
-            <a:pPr algn="ctr" indent="0" marL="0">
+            <a:pPr marL="0" indent="0" algn="ctr">
               <a:buNone/>
             </a:pPr>
             <a:r>
@@ -5172,7 +5170,7 @@
           <a:bodyPr wrap="square" lIns="0" tIns="0" rIns="0" bIns="0" rtlCol="0" anchor="ctr"/>
           <a:lstStyle/>
           <a:p>
-            <a:pPr algn="ctr" indent="0" marL="0">
+            <a:pPr marL="0" indent="0" algn="ctr">
               <a:buNone/>
             </a:pPr>
             <a:r>
@@ -5189,7 +5187,7 @@
             <a:endParaRPr lang="en-US" sz="1050" dirty="0"/>
           </a:p>
           <a:p>
-            <a:pPr algn="ctr" indent="0" marL="0">
+            <a:pPr marL="0" indent="0" algn="ctr">
               <a:buNone/>
             </a:pPr>
             <a:r>
@@ -5206,7 +5204,7 @@
             <a:endParaRPr lang="en-US" sz="1050" dirty="0"/>
           </a:p>
           <a:p>
-            <a:pPr algn="ctr" indent="0" marL="0">
+            <a:pPr marL="0" indent="0" algn="ctr">
               <a:buNone/>
             </a:pPr>
             <a:r>
@@ -5270,7 +5268,7 @@
           <a:bodyPr wrap="square" lIns="0" tIns="0" rIns="0" bIns="0" rtlCol="0" anchor="ctr"/>
           <a:lstStyle/>
           <a:p>
-            <a:pPr algn="ctr" indent="0" marL="0">
+            <a:pPr marL="0" indent="0" algn="ctr">
               <a:buNone/>
             </a:pPr>
             <a:r>
@@ -5306,7 +5304,7 @@
           <a:bodyPr wrap="square" lIns="0" tIns="0" rIns="0" bIns="0" rtlCol="0" anchor="ctr"/>
           <a:lstStyle/>
           <a:p>
-            <a:pPr algn="ctr" indent="0" marL="0">
+            <a:pPr marL="0" indent="0" algn="ctr">
               <a:buNone/>
             </a:pPr>
             <a:r>
@@ -5365,7 +5363,7 @@
           <a:bodyPr wrap="square" lIns="0" tIns="0" rIns="0" bIns="0" rtlCol="0" anchor="ctr"/>
           <a:lstStyle/>
           <a:p>
-            <a:pPr algn="ctr" indent="0" marL="0">
+            <a:pPr marL="0" indent="0" algn="ctr">
               <a:buNone/>
             </a:pPr>
             <a:r>
@@ -5382,7 +5380,7 @@
             <a:endParaRPr lang="en-US" sz="1050" dirty="0"/>
           </a:p>
           <a:p>
-            <a:pPr algn="ctr" indent="0" marL="0">
+            <a:pPr marL="0" indent="0" algn="ctr">
               <a:buNone/>
             </a:pPr>
             <a:r>
@@ -5399,7 +5397,7 @@
             <a:endParaRPr lang="en-US" sz="1050" dirty="0"/>
           </a:p>
           <a:p>
-            <a:pPr algn="ctr" indent="0" marL="0">
+            <a:pPr marL="0" indent="0" algn="ctr">
               <a:buNone/>
             </a:pPr>
             <a:r>
@@ -5503,7 +5501,7 @@
           <a:bodyPr wrap="square" lIns="0" tIns="0" rIns="0" bIns="0" rtlCol="0" anchor="ctr"/>
           <a:lstStyle/>
           <a:p>
-            <a:pPr indent="0" marL="0">
+            <a:pPr marL="0" indent="0">
               <a:buNone/>
             </a:pPr>
             <a:r>
@@ -5567,7 +5565,7 @@
           <a:bodyPr wrap="square" lIns="0" tIns="0" rIns="0" bIns="0" rtlCol="0" anchor="ctr"/>
           <a:lstStyle/>
           <a:p>
-            <a:pPr indent="0" marL="0">
+            <a:pPr marL="0" indent="0">
               <a:buNone/>
             </a:pPr>
             <a:r>
@@ -5606,7 +5604,7 @@
           <a:bodyPr wrap="square" lIns="0" tIns="0" rIns="0" bIns="0" rtlCol="0" anchor="ctr"/>
           <a:lstStyle/>
           <a:p>
-            <a:pPr indent="0" marL="0">
+            <a:pPr marL="0" indent="0">
               <a:buNone/>
             </a:pPr>
             <a:r>
@@ -5665,7 +5663,7 @@
           <a:bodyPr wrap="square" lIns="0" tIns="0" rIns="0" bIns="0" rtlCol="0" anchor="ctr"/>
           <a:lstStyle/>
           <a:p>
-            <a:pPr algn="ctr" indent="0" marL="0">
+            <a:pPr marL="0" indent="0" algn="ctr">
               <a:buNone/>
             </a:pPr>
             <a:r>
@@ -5729,7 +5727,7 @@
           <a:bodyPr wrap="square" lIns="0" tIns="0" rIns="0" bIns="0" rtlCol="0" anchor="ctr"/>
           <a:lstStyle/>
           <a:p>
-            <a:pPr indent="0" marL="0">
+            <a:pPr marL="0" indent="0">
               <a:buNone/>
             </a:pPr>
             <a:r>
@@ -5768,7 +5766,7 @@
           <a:bodyPr wrap="square" lIns="0" tIns="0" rIns="0" bIns="0" rtlCol="0" anchor="ctr"/>
           <a:lstStyle/>
           <a:p>
-            <a:pPr indent="0" marL="0">
+            <a:pPr marL="0" indent="0">
               <a:buNone/>
             </a:pPr>
             <a:r>
@@ -5827,7 +5825,7 @@
           <a:bodyPr wrap="square" lIns="0" tIns="0" rIns="0" bIns="0" rtlCol="0" anchor="ctr"/>
           <a:lstStyle/>
           <a:p>
-            <a:pPr algn="ctr" indent="0" marL="0">
+            <a:pPr marL="0" indent="0" algn="ctr">
               <a:buNone/>
             </a:pPr>
             <a:r>
@@ -5891,7 +5889,7 @@
           <a:bodyPr wrap="square" lIns="0" tIns="0" rIns="0" bIns="0" rtlCol="0" anchor="ctr"/>
           <a:lstStyle/>
           <a:p>
-            <a:pPr indent="0" marL="0">
+            <a:pPr marL="0" indent="0">
               <a:buNone/>
             </a:pPr>
             <a:r>
@@ -5930,7 +5928,7 @@
           <a:bodyPr wrap="square" lIns="0" tIns="0" rIns="0" bIns="0" rtlCol="0" anchor="ctr"/>
           <a:lstStyle/>
           <a:p>
-            <a:pPr indent="0" marL="0">
+            <a:pPr marL="0" indent="0">
               <a:buNone/>
             </a:pPr>
             <a:r>
@@ -5989,7 +5987,7 @@
           <a:bodyPr wrap="square" lIns="0" tIns="0" rIns="0" bIns="0" rtlCol="0" anchor="ctr"/>
           <a:lstStyle/>
           <a:p>
-            <a:pPr algn="ctr" indent="0" marL="0">
+            <a:pPr marL="0" indent="0" algn="ctr">
               <a:buNone/>
             </a:pPr>
             <a:r>
@@ -6053,7 +6051,7 @@
           <a:bodyPr wrap="square" lIns="0" tIns="0" rIns="0" bIns="0" rtlCol="0" anchor="ctr"/>
           <a:lstStyle/>
           <a:p>
-            <a:pPr indent="0" marL="0">
+            <a:pPr marL="0" indent="0">
               <a:buNone/>
             </a:pPr>
             <a:r>
@@ -6092,7 +6090,7 @@
           <a:bodyPr wrap="square" lIns="0" tIns="0" rIns="0" bIns="0" rtlCol="0" anchor="ctr"/>
           <a:lstStyle/>
           <a:p>
-            <a:pPr indent="0" marL="0">
+            <a:pPr marL="0" indent="0">
               <a:buNone/>
             </a:pPr>
             <a:r>
@@ -6151,7 +6149,7 @@
           <a:bodyPr wrap="square" lIns="0" tIns="0" rIns="0" bIns="0" rtlCol="0" anchor="ctr"/>
           <a:lstStyle/>
           <a:p>
-            <a:pPr algn="ctr" indent="0" marL="0">
+            <a:pPr marL="0" indent="0" algn="ctr">
               <a:buNone/>
             </a:pPr>
             <a:r>
@@ -6215,7 +6213,7 @@
           <a:bodyPr wrap="square" lIns="0" tIns="0" rIns="0" bIns="0" rtlCol="0" anchor="ctr"/>
           <a:lstStyle/>
           <a:p>
-            <a:pPr indent="0" marL="0">
+            <a:pPr marL="0" indent="0">
               <a:buNone/>
             </a:pPr>
             <a:r>
@@ -6254,7 +6252,7 @@
           <a:bodyPr wrap="square" lIns="0" tIns="0" rIns="0" bIns="0" rtlCol="0" anchor="ctr"/>
           <a:lstStyle/>
           <a:p>
-            <a:pPr indent="0" marL="0">
+            <a:pPr marL="0" indent="0">
               <a:buNone/>
             </a:pPr>
             <a:r>
@@ -6313,7 +6311,7 @@
           <a:bodyPr wrap="square" lIns="0" tIns="0" rIns="0" bIns="0" rtlCol="0" anchor="ctr"/>
           <a:lstStyle/>
           <a:p>
-            <a:pPr algn="ctr" indent="0" marL="0">
+            <a:pPr marL="0" indent="0" algn="ctr">
               <a:buNone/>
             </a:pPr>
             <a:r>
@@ -6377,7 +6375,7 @@
           <a:bodyPr wrap="square" lIns="0" tIns="0" rIns="0" bIns="0" rtlCol="0" anchor="ctr"/>
           <a:lstStyle/>
           <a:p>
-            <a:pPr indent="0" marL="0">
+            <a:pPr marL="0" indent="0">
               <a:buNone/>
             </a:pPr>
             <a:r>
@@ -6416,7 +6414,7 @@
           <a:bodyPr wrap="square" lIns="0" tIns="0" rIns="0" bIns="0" rtlCol="0" anchor="ctr"/>
           <a:lstStyle/>
           <a:p>
-            <a:pPr indent="0" marL="0">
+            <a:pPr marL="0" indent="0">
               <a:buNone/>
             </a:pPr>
             <a:r>
@@ -6475,7 +6473,7 @@
           <a:bodyPr wrap="square" lIns="0" tIns="0" rIns="0" bIns="0" rtlCol="0" anchor="ctr"/>
           <a:lstStyle/>
           <a:p>
-            <a:pPr algn="ctr" indent="0" marL="0">
+            <a:pPr marL="0" indent="0" algn="ctr">
               <a:buNone/>
             </a:pPr>
             <a:r>
@@ -6579,7 +6577,7 @@
           <a:bodyPr wrap="square" lIns="0" tIns="0" rIns="0" bIns="0" rtlCol="0" anchor="ctr"/>
           <a:lstStyle/>
           <a:p>
-            <a:pPr indent="0" marL="0">
+            <a:pPr marL="0" indent="0">
               <a:buNone/>
             </a:pPr>
             <a:r>
@@ -6663,7 +6661,7 @@
           <a:bodyPr wrap="square" lIns="0" tIns="0" rIns="0" bIns="0" rtlCol="0" anchor="ctr"/>
           <a:lstStyle/>
           <a:p>
-            <a:pPr indent="0" marL="0">
+            <a:pPr marL="0" indent="0">
               <a:buNone/>
             </a:pPr>
             <a:r>
@@ -6702,7 +6700,7 @@
           <a:bodyPr wrap="square" lIns="0" tIns="0" rIns="0" bIns="0" rtlCol="0" anchor="ctr"/>
           <a:lstStyle/>
           <a:p>
-            <a:pPr indent="0" marL="0">
+            <a:pPr marL="0" indent="0">
               <a:buNone/>
             </a:pPr>
             <a:r>
@@ -6786,7 +6784,7 @@
           <a:bodyPr wrap="square" lIns="0" tIns="0" rIns="0" bIns="0" rtlCol="0" anchor="ctr"/>
           <a:lstStyle/>
           <a:p>
-            <a:pPr indent="0" marL="0">
+            <a:pPr marL="0" indent="0">
               <a:buNone/>
             </a:pPr>
             <a:r>
@@ -6825,7 +6823,7 @@
           <a:bodyPr wrap="square" lIns="0" tIns="0" rIns="0" bIns="0" rtlCol="0" anchor="ctr"/>
           <a:lstStyle/>
           <a:p>
-            <a:pPr indent="0" marL="0">
+            <a:pPr marL="0" indent="0">
               <a:buNone/>
             </a:pPr>
             <a:r>
@@ -6909,7 +6907,7 @@
           <a:bodyPr wrap="square" lIns="0" tIns="0" rIns="0" bIns="0" rtlCol="0" anchor="ctr"/>
           <a:lstStyle/>
           <a:p>
-            <a:pPr indent="0" marL="0">
+            <a:pPr marL="0" indent="0">
               <a:buNone/>
             </a:pPr>
             <a:r>
@@ -6948,7 +6946,7 @@
           <a:bodyPr wrap="square" lIns="0" tIns="0" rIns="0" bIns="0" rtlCol="0" anchor="ctr"/>
           <a:lstStyle/>
           <a:p>
-            <a:pPr indent="0" marL="0">
+            <a:pPr marL="0" indent="0">
               <a:buNone/>
             </a:pPr>
             <a:r>
@@ -7032,7 +7030,7 @@
           <a:bodyPr wrap="square" lIns="0" tIns="0" rIns="0" bIns="0" rtlCol="0" anchor="ctr"/>
           <a:lstStyle/>
           <a:p>
-            <a:pPr indent="0" marL="0">
+            <a:pPr marL="0" indent="0">
               <a:buNone/>
             </a:pPr>
             <a:r>
@@ -7071,7 +7069,7 @@
           <a:bodyPr wrap="square" lIns="0" tIns="0" rIns="0" bIns="0" rtlCol="0" anchor="ctr"/>
           <a:lstStyle/>
           <a:p>
-            <a:pPr indent="0" marL="0">
+            <a:pPr marL="0" indent="0">
               <a:buNone/>
             </a:pPr>
             <a:r>
@@ -7155,7 +7153,7 @@
           <a:bodyPr wrap="square" lIns="0" tIns="0" rIns="0" bIns="0" rtlCol="0" anchor="ctr"/>
           <a:lstStyle/>
           <a:p>
-            <a:pPr indent="0" marL="0">
+            <a:pPr marL="0" indent="0">
               <a:buNone/>
             </a:pPr>
             <a:r>
@@ -7194,7 +7192,7 @@
           <a:bodyPr wrap="square" lIns="0" tIns="0" rIns="0" bIns="0" rtlCol="0" anchor="ctr"/>
           <a:lstStyle/>
           <a:p>
-            <a:pPr indent="0" marL="0">
+            <a:pPr marL="0" indent="0">
               <a:buNone/>
             </a:pPr>
             <a:r>
@@ -7278,7 +7276,7 @@
           <a:bodyPr wrap="square" lIns="0" tIns="0" rIns="0" bIns="0" rtlCol="0" anchor="ctr"/>
           <a:lstStyle/>
           <a:p>
-            <a:pPr indent="0" marL="0">
+            <a:pPr marL="0" indent="0">
               <a:buNone/>
             </a:pPr>
             <a:r>
@@ -7317,7 +7315,7 @@
           <a:bodyPr wrap="square" lIns="0" tIns="0" rIns="0" bIns="0" rtlCol="0" anchor="ctr"/>
           <a:lstStyle/>
           <a:p>
-            <a:pPr indent="0" marL="0">
+            <a:pPr marL="0" indent="0">
               <a:buNone/>
             </a:pPr>
             <a:r>
@@ -7401,7 +7399,7 @@
           <a:bodyPr wrap="square" lIns="0" tIns="0" rIns="0" bIns="0" rtlCol="0" anchor="ctr"/>
           <a:lstStyle/>
           <a:p>
-            <a:pPr indent="0" marL="0">
+            <a:pPr marL="0" indent="0">
               <a:buNone/>
             </a:pPr>
             <a:r>
@@ -7440,7 +7438,7 @@
           <a:bodyPr wrap="square" lIns="0" tIns="0" rIns="0" bIns="0" rtlCol="0" anchor="ctr"/>
           <a:lstStyle/>
           <a:p>
-            <a:pPr indent="0" marL="0">
+            <a:pPr marL="0" indent="0">
               <a:buNone/>
             </a:pPr>
             <a:r>
@@ -7524,7 +7522,7 @@
           <a:bodyPr wrap="square" lIns="0" tIns="0" rIns="0" bIns="0" rtlCol="0" anchor="ctr"/>
           <a:lstStyle/>
           <a:p>
-            <a:pPr indent="0" marL="0">
+            <a:pPr marL="0" indent="0">
               <a:buNone/>
             </a:pPr>
             <a:r>
@@ -7563,7 +7561,7 @@
           <a:bodyPr wrap="square" lIns="0" tIns="0" rIns="0" bIns="0" rtlCol="0" anchor="ctr"/>
           <a:lstStyle/>
           <a:p>
-            <a:pPr indent="0" marL="0">
+            <a:pPr marL="0" indent="0">
               <a:buNone/>
             </a:pPr>
             <a:r>
@@ -7575,7 +7573,7 @@
                 <a:ea typeface="Arial" pitchFamily="34" charset="-122"/>
                 <a:cs typeface="Arial" pitchFamily="34" charset="-120"/>
               </a:rPr>
-              <a:t>Wave · CinetPay · Orange Money</a:t>
+              <a:t>    Wave · Orange Money</a:t>
             </a:r>
             <a:endParaRPr lang="en-US" sz="1100" dirty="0"/>
           </a:p>
@@ -7614,7 +7612,7 @@
         </p:nvSpPr>
         <p:spPr>
           <a:xfrm>
-            <a:off x="0" y="0"/>
+            <a:off x="0" y="259210"/>
             <a:ext cx="9144000" cy="5143500"/>
           </a:xfrm>
           <a:prstGeom prst="rect">
@@ -7667,7 +7665,7 @@
           <a:bodyPr wrap="square" lIns="0" tIns="0" rIns="0" bIns="0" rtlCol="0" anchor="ctr"/>
           <a:lstStyle/>
           <a:p>
-            <a:pPr indent="0" marL="0">
+            <a:pPr marL="0" indent="0">
               <a:buNone/>
             </a:pPr>
             <a:r>
@@ -7693,8 +7691,8 @@
         </p:nvSpPr>
         <p:spPr>
           <a:xfrm>
-            <a:off x="457200" y="2468880"/>
-            <a:ext cx="8229600" cy="73152"/>
+            <a:off x="257500" y="2510920"/>
+            <a:ext cx="8520740" cy="45719"/>
           </a:xfrm>
           <a:prstGeom prst="rect">
             <a:avLst/>
@@ -7713,7 +7711,7 @@
         </p:nvSpPr>
         <p:spPr>
           <a:xfrm>
-            <a:off x="1143000" y="2377440"/>
+            <a:off x="859223" y="2419480"/>
             <a:ext cx="237744" cy="237744"/>
           </a:xfrm>
           <a:prstGeom prst="ellipse">
@@ -7733,7 +7731,7 @@
         </p:nvSpPr>
         <p:spPr>
           <a:xfrm>
-            <a:off x="731520" y="822960"/>
+            <a:off x="184990" y="865000"/>
             <a:ext cx="1554480" cy="1463040"/>
           </a:xfrm>
           <a:prstGeom prst="rect">
@@ -7758,7 +7756,7 @@
         </p:nvSpPr>
         <p:spPr>
           <a:xfrm>
-            <a:off x="777240" y="868680"/>
+            <a:off x="451423" y="910720"/>
             <a:ext cx="1463040" cy="274320"/>
           </a:xfrm>
           <a:prstGeom prst="rect">
@@ -7771,7 +7769,7 @@
           <a:bodyPr wrap="square" lIns="0" tIns="0" rIns="0" bIns="0" rtlCol="0" anchor="ctr"/>
           <a:lstStyle/>
           <a:p>
-            <a:pPr indent="0" marL="0">
+            <a:pPr marL="0" indent="0">
               <a:buNone/>
             </a:pPr>
             <a:r>
@@ -7797,7 +7795,7 @@
         </p:nvSpPr>
         <p:spPr>
           <a:xfrm>
-            <a:off x="777240" y="1143000"/>
+            <a:off x="241220" y="1185040"/>
             <a:ext cx="1463040" cy="256032"/>
           </a:xfrm>
           <a:prstGeom prst="rect">
@@ -7810,7 +7808,7 @@
           <a:bodyPr wrap="square" lIns="0" tIns="0" rIns="0" bIns="0" rtlCol="0" anchor="ctr"/>
           <a:lstStyle/>
           <a:p>
-            <a:pPr indent="0" marL="0">
+            <a:pPr marL="0" indent="0">
               <a:buNone/>
             </a:pPr>
             <a:r>
@@ -7836,7 +7834,7 @@
         </p:nvSpPr>
         <p:spPr>
           <a:xfrm>
-            <a:off x="777240" y="1417320"/>
+            <a:off x="241220" y="1459360"/>
             <a:ext cx="1463040" cy="228600"/>
           </a:xfrm>
           <a:prstGeom prst="rect">
@@ -7849,7 +7847,7 @@
           <a:bodyPr wrap="square" lIns="0" tIns="0" rIns="0" bIns="0" rtlCol="0" anchor="ctr"/>
           <a:lstStyle/>
           <a:p>
-            <a:pPr indent="0" marL="0">
+            <a:pPr marL="0" indent="0">
               <a:buNone/>
             </a:pPr>
             <a:r>
@@ -7875,7 +7873,7 @@
         </p:nvSpPr>
         <p:spPr>
           <a:xfrm>
-            <a:off x="731520" y="2697480"/>
+            <a:off x="195500" y="2739520"/>
             <a:ext cx="1554480" cy="1600200"/>
           </a:xfrm>
           <a:prstGeom prst="rect">
@@ -7900,7 +7898,7 @@
         </p:nvSpPr>
         <p:spPr>
           <a:xfrm>
-            <a:off x="822960" y="2788920"/>
+            <a:off x="286940" y="2830960"/>
             <a:ext cx="1371600" cy="1417320"/>
           </a:xfrm>
           <a:prstGeom prst="rect">
@@ -7913,7 +7911,7 @@
           <a:bodyPr wrap="square" lIns="0" tIns="0" rIns="0" bIns="0" rtlCol="0" anchor="ctr"/>
           <a:lstStyle/>
           <a:p>
-            <a:pPr indent="0" marL="0">
+            <a:pPr marL="0" indent="0">
               <a:buNone/>
             </a:pPr>
             <a:r>
@@ -7930,7 +7928,7 @@
             <a:endParaRPr lang="en-US" sz="1000" dirty="0"/>
           </a:p>
           <a:p>
-            <a:pPr indent="0" marL="0">
+            <a:pPr marL="0" indent="0">
               <a:buNone/>
             </a:pPr>
             <a:r>
@@ -7947,7 +7945,7 @@
             <a:endParaRPr lang="en-US" sz="1000" dirty="0"/>
           </a:p>
           <a:p>
-            <a:pPr indent="0" marL="0">
+            <a:pPr marL="0" indent="0">
               <a:buNone/>
             </a:pPr>
             <a:r>
@@ -7973,7 +7971,7 @@
         </p:nvSpPr>
         <p:spPr>
           <a:xfrm>
-            <a:off x="2971800" y="2377440"/>
+            <a:off x="2582920" y="2419480"/>
             <a:ext cx="237744" cy="237744"/>
           </a:xfrm>
           <a:prstGeom prst="ellipse">
@@ -7993,7 +7991,7 @@
         </p:nvSpPr>
         <p:spPr>
           <a:xfrm>
-            <a:off x="2560320" y="822960"/>
+            <a:off x="2013790" y="865000"/>
             <a:ext cx="1554480" cy="1463040"/>
           </a:xfrm>
           <a:prstGeom prst="rect">
@@ -8018,7 +8016,7 @@
         </p:nvSpPr>
         <p:spPr>
           <a:xfrm>
-            <a:off x="2606040" y="868680"/>
+            <a:off x="2280223" y="910720"/>
             <a:ext cx="1463040" cy="274320"/>
           </a:xfrm>
           <a:prstGeom prst="rect">
@@ -8031,7 +8029,7 @@
           <a:bodyPr wrap="square" lIns="0" tIns="0" rIns="0" bIns="0" rtlCol="0" anchor="ctr"/>
           <a:lstStyle/>
           <a:p>
-            <a:pPr indent="0" marL="0">
+            <a:pPr marL="0" indent="0">
               <a:buNone/>
             </a:pPr>
             <a:r>
@@ -8057,7 +8055,7 @@
         </p:nvSpPr>
         <p:spPr>
           <a:xfrm>
-            <a:off x="2606040" y="1143000"/>
+            <a:off x="2070020" y="1185040"/>
             <a:ext cx="1463040" cy="256032"/>
           </a:xfrm>
           <a:prstGeom prst="rect">
@@ -8070,7 +8068,7 @@
           <a:bodyPr wrap="square" lIns="0" tIns="0" rIns="0" bIns="0" rtlCol="0" anchor="ctr"/>
           <a:lstStyle/>
           <a:p>
-            <a:pPr indent="0" marL="0">
+            <a:pPr marL="0" indent="0">
               <a:buNone/>
             </a:pPr>
             <a:r>
@@ -8096,7 +8094,7 @@
         </p:nvSpPr>
         <p:spPr>
           <a:xfrm>
-            <a:off x="2606040" y="1417320"/>
+            <a:off x="2070020" y="1459360"/>
             <a:ext cx="1463040" cy="228600"/>
           </a:xfrm>
           <a:prstGeom prst="rect">
@@ -8109,7 +8107,7 @@
           <a:bodyPr wrap="square" lIns="0" tIns="0" rIns="0" bIns="0" rtlCol="0" anchor="ctr"/>
           <a:lstStyle/>
           <a:p>
-            <a:pPr indent="0" marL="0">
+            <a:pPr marL="0" indent="0">
               <a:buNone/>
             </a:pPr>
             <a:r>
@@ -8135,7 +8133,7 @@
         </p:nvSpPr>
         <p:spPr>
           <a:xfrm>
-            <a:off x="2560320" y="2697480"/>
+            <a:off x="2024300" y="2739520"/>
             <a:ext cx="1554480" cy="1600200"/>
           </a:xfrm>
           <a:prstGeom prst="rect">
@@ -8160,7 +8158,7 @@
         </p:nvSpPr>
         <p:spPr>
           <a:xfrm>
-            <a:off x="2651760" y="2788920"/>
+            <a:off x="2115740" y="2830960"/>
             <a:ext cx="1371600" cy="1417320"/>
           </a:xfrm>
           <a:prstGeom prst="rect">
@@ -8173,7 +8171,7 @@
           <a:bodyPr wrap="square" lIns="0" tIns="0" rIns="0" bIns="0" rtlCol="0" anchor="ctr"/>
           <a:lstStyle/>
           <a:p>
-            <a:pPr indent="0" marL="0">
+            <a:pPr marL="0" indent="0">
               <a:buNone/>
             </a:pPr>
             <a:r>
@@ -8190,7 +8188,7 @@
             <a:endParaRPr lang="en-US" sz="1000" dirty="0"/>
           </a:p>
           <a:p>
-            <a:pPr indent="0" marL="0">
+            <a:pPr marL="0" indent="0">
               <a:buNone/>
             </a:pPr>
             <a:r>
@@ -8207,7 +8205,7 @@
             <a:endParaRPr lang="en-US" sz="1000" dirty="0"/>
           </a:p>
           <a:p>
-            <a:pPr indent="0" marL="0">
+            <a:pPr marL="0" indent="0">
               <a:buNone/>
             </a:pPr>
             <a:r>
@@ -8233,7 +8231,7 @@
         </p:nvSpPr>
         <p:spPr>
           <a:xfrm>
-            <a:off x="4800600" y="2377440"/>
+            <a:off x="4380190" y="2419480"/>
             <a:ext cx="237744" cy="237744"/>
           </a:xfrm>
           <a:prstGeom prst="ellipse">
@@ -8253,7 +8251,7 @@
         </p:nvSpPr>
         <p:spPr>
           <a:xfrm>
-            <a:off x="4389120" y="822960"/>
+            <a:off x="3842590" y="865000"/>
             <a:ext cx="1554480" cy="1463040"/>
           </a:xfrm>
           <a:prstGeom prst="rect">
@@ -8278,7 +8276,7 @@
         </p:nvSpPr>
         <p:spPr>
           <a:xfrm>
-            <a:off x="4434840" y="868680"/>
+            <a:off x="4109023" y="910720"/>
             <a:ext cx="1463040" cy="274320"/>
           </a:xfrm>
           <a:prstGeom prst="rect">
@@ -8291,7 +8289,7 @@
           <a:bodyPr wrap="square" lIns="0" tIns="0" rIns="0" bIns="0" rtlCol="0" anchor="ctr"/>
           <a:lstStyle/>
           <a:p>
-            <a:pPr indent="0" marL="0">
+            <a:pPr marL="0" indent="0">
               <a:buNone/>
             </a:pPr>
             <a:r>
@@ -8317,7 +8315,7 @@
         </p:nvSpPr>
         <p:spPr>
           <a:xfrm>
-            <a:off x="4434840" y="1143000"/>
+            <a:off x="3898820" y="1185040"/>
             <a:ext cx="1463040" cy="256032"/>
           </a:xfrm>
           <a:prstGeom prst="rect">
@@ -8330,7 +8328,7 @@
           <a:bodyPr wrap="square" lIns="0" tIns="0" rIns="0" bIns="0" rtlCol="0" anchor="ctr"/>
           <a:lstStyle/>
           <a:p>
-            <a:pPr indent="0" marL="0">
+            <a:pPr marL="0" indent="0">
               <a:buNone/>
             </a:pPr>
             <a:r>
@@ -8356,7 +8354,7 @@
         </p:nvSpPr>
         <p:spPr>
           <a:xfrm>
-            <a:off x="4434840" y="1417320"/>
+            <a:off x="3898820" y="1459360"/>
             <a:ext cx="1463040" cy="228600"/>
           </a:xfrm>
           <a:prstGeom prst="rect">
@@ -8369,7 +8367,7 @@
           <a:bodyPr wrap="square" lIns="0" tIns="0" rIns="0" bIns="0" rtlCol="0" anchor="ctr"/>
           <a:lstStyle/>
           <a:p>
-            <a:pPr indent="0" marL="0">
+            <a:pPr marL="0" indent="0">
               <a:buNone/>
             </a:pPr>
             <a:r>
@@ -8395,7 +8393,7 @@
         </p:nvSpPr>
         <p:spPr>
           <a:xfrm>
-            <a:off x="4389120" y="2697480"/>
+            <a:off x="3853100" y="2739520"/>
             <a:ext cx="1554480" cy="1600200"/>
           </a:xfrm>
           <a:prstGeom prst="rect">
@@ -8420,7 +8418,7 @@
         </p:nvSpPr>
         <p:spPr>
           <a:xfrm>
-            <a:off x="4480560" y="2788920"/>
+            <a:off x="3944540" y="2830960"/>
             <a:ext cx="1371600" cy="1417320"/>
           </a:xfrm>
           <a:prstGeom prst="rect">
@@ -8433,7 +8431,7 @@
           <a:bodyPr wrap="square" lIns="0" tIns="0" rIns="0" bIns="0" rtlCol="0" anchor="ctr"/>
           <a:lstStyle/>
           <a:p>
-            <a:pPr indent="0" marL="0">
+            <a:pPr marL="0" indent="0">
               <a:buNone/>
             </a:pPr>
             <a:r>
@@ -8450,7 +8448,7 @@
             <a:endParaRPr lang="en-US" sz="1000" dirty="0"/>
           </a:p>
           <a:p>
-            <a:pPr indent="0" marL="0">
+            <a:pPr marL="0" indent="0">
               <a:buNone/>
             </a:pPr>
             <a:r>
@@ -8467,7 +8465,7 @@
             <a:endParaRPr lang="en-US" sz="1000" dirty="0"/>
           </a:p>
           <a:p>
-            <a:pPr indent="0" marL="0">
+            <a:pPr marL="0" indent="0">
               <a:buNone/>
             </a:pPr>
             <a:r>
@@ -8493,7 +8491,7 @@
         </p:nvSpPr>
         <p:spPr>
           <a:xfrm>
-            <a:off x="6629400" y="2377440"/>
+            <a:off x="6261540" y="2419480"/>
             <a:ext cx="237744" cy="237744"/>
           </a:xfrm>
           <a:prstGeom prst="ellipse">
@@ -8513,7 +8511,7 @@
         </p:nvSpPr>
         <p:spPr>
           <a:xfrm>
-            <a:off x="6217920" y="822960"/>
+            <a:off x="5671390" y="865000"/>
             <a:ext cx="1554480" cy="1463040"/>
           </a:xfrm>
           <a:prstGeom prst="rect">
@@ -8538,7 +8536,7 @@
         </p:nvSpPr>
         <p:spPr>
           <a:xfrm>
-            <a:off x="6263640" y="868680"/>
+            <a:off x="5937823" y="910720"/>
             <a:ext cx="1463040" cy="274320"/>
           </a:xfrm>
           <a:prstGeom prst="rect">
@@ -8551,7 +8549,7 @@
           <a:bodyPr wrap="square" lIns="0" tIns="0" rIns="0" bIns="0" rtlCol="0" anchor="ctr"/>
           <a:lstStyle/>
           <a:p>
-            <a:pPr indent="0" marL="0">
+            <a:pPr marL="0" indent="0">
               <a:buNone/>
             </a:pPr>
             <a:r>
@@ -8577,7 +8575,7 @@
         </p:nvSpPr>
         <p:spPr>
           <a:xfrm>
-            <a:off x="6263640" y="1143000"/>
+            <a:off x="5727620" y="1185040"/>
             <a:ext cx="1463040" cy="256032"/>
           </a:xfrm>
           <a:prstGeom prst="rect">
@@ -8590,7 +8588,7 @@
           <a:bodyPr wrap="square" lIns="0" tIns="0" rIns="0" bIns="0" rtlCol="0" anchor="ctr"/>
           <a:lstStyle/>
           <a:p>
-            <a:pPr indent="0" marL="0">
+            <a:pPr marL="0" indent="0">
               <a:buNone/>
             </a:pPr>
             <a:r>
@@ -8616,7 +8614,7 @@
         </p:nvSpPr>
         <p:spPr>
           <a:xfrm>
-            <a:off x="6263640" y="1417320"/>
+            <a:off x="5727620" y="1459360"/>
             <a:ext cx="1463040" cy="228600"/>
           </a:xfrm>
           <a:prstGeom prst="rect">
@@ -8629,7 +8627,7 @@
           <a:bodyPr wrap="square" lIns="0" tIns="0" rIns="0" bIns="0" rtlCol="0" anchor="ctr"/>
           <a:lstStyle/>
           <a:p>
-            <a:pPr indent="0" marL="0">
+            <a:pPr marL="0" indent="0">
               <a:buNone/>
             </a:pPr>
             <a:r>
@@ -8655,7 +8653,7 @@
         </p:nvSpPr>
         <p:spPr>
           <a:xfrm>
-            <a:off x="6217920" y="2697480"/>
+            <a:off x="5681900" y="2739520"/>
             <a:ext cx="1554480" cy="1600200"/>
           </a:xfrm>
           <a:prstGeom prst="rect">
@@ -8680,7 +8678,7 @@
         </p:nvSpPr>
         <p:spPr>
           <a:xfrm>
-            <a:off x="6309360" y="2788920"/>
+            <a:off x="5773340" y="2830960"/>
             <a:ext cx="1371600" cy="1417320"/>
           </a:xfrm>
           <a:prstGeom prst="rect">
@@ -8693,7 +8691,7 @@
           <a:bodyPr wrap="square" lIns="0" tIns="0" rIns="0" bIns="0" rtlCol="0" anchor="ctr"/>
           <a:lstStyle/>
           <a:p>
-            <a:pPr indent="0" marL="0">
+            <a:pPr marL="0" indent="0">
               <a:buNone/>
             </a:pPr>
             <a:r>
@@ -8710,7 +8708,7 @@
             <a:endParaRPr lang="en-US" sz="1000" dirty="0"/>
           </a:p>
           <a:p>
-            <a:pPr indent="0" marL="0">
+            <a:pPr marL="0" indent="0">
               <a:buNone/>
             </a:pPr>
             <a:r>
@@ -8727,7 +8725,7 @@
             <a:endParaRPr lang="en-US" sz="1000" dirty="0"/>
           </a:p>
           <a:p>
-            <a:pPr indent="0" marL="0">
+            <a:pPr marL="0" indent="0">
               <a:buNone/>
             </a:pPr>
             <a:r>
@@ -8753,7 +8751,7 @@
         </p:nvSpPr>
         <p:spPr>
           <a:xfrm>
-            <a:off x="8183880" y="2377440"/>
+            <a:off x="7973673" y="2419480"/>
             <a:ext cx="237744" cy="237744"/>
           </a:xfrm>
           <a:prstGeom prst="ellipse">
@@ -8773,7 +8771,7 @@
         </p:nvSpPr>
         <p:spPr>
           <a:xfrm>
-            <a:off x="7772400" y="822960"/>
+            <a:off x="7383523" y="865000"/>
             <a:ext cx="1554480" cy="1463040"/>
           </a:xfrm>
           <a:prstGeom prst="rect">
@@ -8798,7 +8796,7 @@
         </p:nvSpPr>
         <p:spPr>
           <a:xfrm>
-            <a:off x="7818120" y="868680"/>
+            <a:off x="7649956" y="910720"/>
             <a:ext cx="1463040" cy="274320"/>
           </a:xfrm>
           <a:prstGeom prst="rect">
@@ -8811,7 +8809,7 @@
           <a:bodyPr wrap="square" lIns="0" tIns="0" rIns="0" bIns="0" rtlCol="0" anchor="ctr"/>
           <a:lstStyle/>
           <a:p>
-            <a:pPr indent="0" marL="0">
+            <a:pPr marL="0" indent="0">
               <a:buNone/>
             </a:pPr>
             <a:r>
@@ -8837,7 +8835,7 @@
         </p:nvSpPr>
         <p:spPr>
           <a:xfrm>
-            <a:off x="7818120" y="1143000"/>
+            <a:off x="7439753" y="1185040"/>
             <a:ext cx="1463040" cy="256032"/>
           </a:xfrm>
           <a:prstGeom prst="rect">
@@ -8850,7 +8848,7 @@
           <a:bodyPr wrap="square" lIns="0" tIns="0" rIns="0" bIns="0" rtlCol="0" anchor="ctr"/>
           <a:lstStyle/>
           <a:p>
-            <a:pPr indent="0" marL="0">
+            <a:pPr marL="0" indent="0">
               <a:buNone/>
             </a:pPr>
             <a:r>
@@ -8876,7 +8874,7 @@
         </p:nvSpPr>
         <p:spPr>
           <a:xfrm>
-            <a:off x="7818120" y="1417320"/>
+            <a:off x="7439753" y="1459360"/>
             <a:ext cx="1463040" cy="228600"/>
           </a:xfrm>
           <a:prstGeom prst="rect">
@@ -8889,7 +8887,7 @@
           <a:bodyPr wrap="square" lIns="0" tIns="0" rIns="0" bIns="0" rtlCol="0" anchor="ctr"/>
           <a:lstStyle/>
           <a:p>
-            <a:pPr indent="0" marL="0">
+            <a:pPr marL="0" indent="0">
               <a:buNone/>
             </a:pPr>
             <a:r>
@@ -8915,7 +8913,7 @@
         </p:nvSpPr>
         <p:spPr>
           <a:xfrm>
-            <a:off x="7772400" y="2697480"/>
+            <a:off x="7394033" y="2739520"/>
             <a:ext cx="1554480" cy="1600200"/>
           </a:xfrm>
           <a:prstGeom prst="rect">
@@ -8940,7 +8938,7 @@
         </p:nvSpPr>
         <p:spPr>
           <a:xfrm>
-            <a:off x="7863840" y="2788920"/>
+            <a:off x="7485473" y="2830960"/>
             <a:ext cx="1371600" cy="1417320"/>
           </a:xfrm>
           <a:prstGeom prst="rect">
@@ -8953,7 +8951,7 @@
           <a:bodyPr wrap="square" lIns="0" tIns="0" rIns="0" bIns="0" rtlCol="0" anchor="ctr"/>
           <a:lstStyle/>
           <a:p>
-            <a:pPr indent="0" marL="0">
+            <a:pPr marL="0" indent="0">
               <a:buNone/>
             </a:pPr>
             <a:r>
@@ -8970,7 +8968,7 @@
             <a:endParaRPr lang="en-US" sz="1000" dirty="0"/>
           </a:p>
           <a:p>
-            <a:pPr indent="0" marL="0">
+            <a:pPr marL="0" indent="0">
               <a:buNone/>
             </a:pPr>
             <a:r>
@@ -8987,7 +8985,7 @@
             <a:endParaRPr lang="en-US" sz="1000" dirty="0"/>
           </a:p>
           <a:p>
-            <a:pPr indent="0" marL="0">
+            <a:pPr marL="0" indent="0">
               <a:buNone/>
             </a:pPr>
             <a:r>
@@ -9091,7 +9089,7 @@
           <a:bodyPr wrap="square" lIns="0" tIns="0" rIns="0" bIns="0" rtlCol="0" anchor="ctr"/>
           <a:lstStyle/>
           <a:p>
-            <a:pPr indent="0" marL="0">
+            <a:pPr marL="0" indent="0">
               <a:buNone/>
             </a:pPr>
             <a:r>
@@ -9155,7 +9153,7 @@
           <a:bodyPr wrap="square" lIns="0" tIns="0" rIns="0" bIns="0" rtlCol="0" anchor="ctr"/>
           <a:lstStyle/>
           <a:p>
-            <a:pPr algn="ctr" indent="0" marL="0">
+            <a:pPr marL="0" indent="0" algn="ctr">
               <a:buNone/>
             </a:pPr>
             <a:r>
@@ -9194,7 +9192,7 @@
           <a:bodyPr wrap="square" lIns="0" tIns="0" rIns="0" bIns="0" rtlCol="0" anchor="ctr"/>
           <a:lstStyle/>
           <a:p>
-            <a:pPr algn="ctr" indent="0" marL="0">
+            <a:pPr marL="0" indent="0" algn="ctr">
               <a:buNone/>
             </a:pPr>
             <a:r>
@@ -9253,7 +9251,7 @@
           <a:bodyPr wrap="square" lIns="0" tIns="0" rIns="0" bIns="0" rtlCol="0" anchor="ctr"/>
           <a:lstStyle/>
           <a:p>
-            <a:pPr indent="0" marL="0">
+            <a:pPr marL="0" indent="0">
               <a:buNone/>
             </a:pPr>
             <a:r>
@@ -9292,7 +9290,7 @@
           <a:bodyPr wrap="square" lIns="0" tIns="0" rIns="0" bIns="0" rtlCol="0" anchor="ctr"/>
           <a:lstStyle/>
           <a:p>
-            <a:pPr algn="r" indent="0" marL="0">
+            <a:pPr marL="0" indent="0" algn="r">
               <a:buNone/>
             </a:pPr>
             <a:r>
@@ -9351,7 +9349,7 @@
           <a:bodyPr wrap="square" lIns="0" tIns="0" rIns="0" bIns="0" rtlCol="0" anchor="ctr"/>
           <a:lstStyle/>
           <a:p>
-            <a:pPr indent="0" marL="0">
+            <a:pPr marL="0" indent="0">
               <a:buNone/>
             </a:pPr>
             <a:r>
@@ -9390,7 +9388,7 @@
           <a:bodyPr wrap="square" lIns="0" tIns="0" rIns="0" bIns="0" rtlCol="0" anchor="ctr"/>
           <a:lstStyle/>
           <a:p>
-            <a:pPr algn="r" indent="0" marL="0">
+            <a:pPr marL="0" indent="0" algn="r">
               <a:buNone/>
             </a:pPr>
             <a:r>
@@ -9449,7 +9447,7 @@
           <a:bodyPr wrap="square" lIns="0" tIns="0" rIns="0" bIns="0" rtlCol="0" anchor="ctr"/>
           <a:lstStyle/>
           <a:p>
-            <a:pPr indent="0" marL="0">
+            <a:pPr marL="0" indent="0">
               <a:buNone/>
             </a:pPr>
             <a:r>
@@ -9488,7 +9486,7 @@
           <a:bodyPr wrap="square" lIns="0" tIns="0" rIns="0" bIns="0" rtlCol="0" anchor="ctr"/>
           <a:lstStyle/>
           <a:p>
-            <a:pPr algn="r" indent="0" marL="0">
+            <a:pPr marL="0" indent="0" algn="r">
               <a:buNone/>
             </a:pPr>
             <a:r>
@@ -9547,7 +9545,7 @@
           <a:bodyPr wrap="square" lIns="0" tIns="0" rIns="0" bIns="0" rtlCol="0" anchor="ctr"/>
           <a:lstStyle/>
           <a:p>
-            <a:pPr indent="0" marL="0">
+            <a:pPr marL="0" indent="0">
               <a:buNone/>
             </a:pPr>
             <a:r>
@@ -9586,7 +9584,7 @@
           <a:bodyPr wrap="square" lIns="0" tIns="0" rIns="0" bIns="0" rtlCol="0" anchor="ctr"/>
           <a:lstStyle/>
           <a:p>
-            <a:pPr algn="r" indent="0" marL="0">
+            <a:pPr marL="0" indent="0" algn="r">
               <a:buNone/>
             </a:pPr>
             <a:r>
@@ -9645,7 +9643,7 @@
           <a:bodyPr wrap="square" lIns="0" tIns="0" rIns="0" bIns="0" rtlCol="0" anchor="ctr"/>
           <a:lstStyle/>
           <a:p>
-            <a:pPr indent="0" marL="0">
+            <a:pPr marL="0" indent="0">
               <a:buNone/>
             </a:pPr>
             <a:r>
@@ -9684,7 +9682,7 @@
           <a:bodyPr wrap="square" lIns="0" tIns="0" rIns="0" bIns="0" rtlCol="0" anchor="ctr"/>
           <a:lstStyle/>
           <a:p>
-            <a:pPr algn="r" indent="0" marL="0">
+            <a:pPr marL="0" indent="0" algn="r">
               <a:buNone/>
             </a:pPr>
             <a:r>
@@ -9743,7 +9741,7 @@
           <a:bodyPr wrap="square" lIns="0" tIns="0" rIns="0" bIns="0" rtlCol="0" anchor="ctr"/>
           <a:lstStyle/>
           <a:p>
-            <a:pPr indent="0" marL="0">
+            <a:pPr marL="0" indent="0">
               <a:buNone/>
             </a:pPr>
             <a:r>
@@ -9782,7 +9780,7 @@
           <a:bodyPr wrap="square" lIns="0" tIns="0" rIns="0" bIns="0" rtlCol="0" anchor="ctr"/>
           <a:lstStyle/>
           <a:p>
-            <a:pPr algn="r" indent="0" marL="0">
+            <a:pPr marL="0" indent="0" algn="r">
               <a:buNone/>
             </a:pPr>
             <a:r>
@@ -9841,7 +9839,7 @@
           <a:bodyPr wrap="square" lIns="0" tIns="0" rIns="0" bIns="0" rtlCol="0" anchor="ctr"/>
           <a:lstStyle/>
           <a:p>
-            <a:pPr indent="0" marL="0">
+            <a:pPr marL="0" indent="0">
               <a:buNone/>
             </a:pPr>
             <a:r>
@@ -9880,7 +9878,7 @@
           <a:bodyPr wrap="square" lIns="0" tIns="0" rIns="0" bIns="0" rtlCol="0" anchor="ctr"/>
           <a:lstStyle/>
           <a:p>
-            <a:pPr algn="r" indent="0" marL="0">
+            <a:pPr marL="0" indent="0" algn="r">
               <a:buNone/>
             </a:pPr>
             <a:r>
@@ -10219,4 +10217,299 @@
     </a:ext>
   </a:extLst>
 </a:theme>
+</file>
+
+<file path=ppt/theme/theme2.xml><?xml version="1.0" encoding="utf-8"?>
+<a:theme xmlns:a="http://schemas.openxmlformats.org/drawingml/2006/main" name="Thème Office">
+  <a:themeElements>
+    <a:clrScheme name="Office">
+      <a:dk1>
+        <a:sysClr val="windowText" lastClr="000000"/>
+      </a:dk1>
+      <a:lt1>
+        <a:sysClr val="window" lastClr="FFFFFF"/>
+      </a:lt1>
+      <a:dk2>
+        <a:srgbClr val="44546A"/>
+      </a:dk2>
+      <a:lt2>
+        <a:srgbClr val="E7E6E6"/>
+      </a:lt2>
+      <a:accent1>
+        <a:srgbClr val="4472C4"/>
+      </a:accent1>
+      <a:accent2>
+        <a:srgbClr val="ED7D31"/>
+      </a:accent2>
+      <a:accent3>
+        <a:srgbClr val="A5A5A5"/>
+      </a:accent3>
+      <a:accent4>
+        <a:srgbClr val="FFC000"/>
+      </a:accent4>
+      <a:accent5>
+        <a:srgbClr val="5B9BD5"/>
+      </a:accent5>
+      <a:accent6>
+        <a:srgbClr val="70AD47"/>
+      </a:accent6>
+      <a:hlink>
+        <a:srgbClr val="0563C1"/>
+      </a:hlink>
+      <a:folHlink>
+        <a:srgbClr val="954F72"/>
+      </a:folHlink>
+    </a:clrScheme>
+    <a:fontScheme name="Office">
+      <a:majorFont>
+        <a:latin typeface="Calibri Light" panose="020F0302020204030204"/>
+        <a:ea typeface=""/>
+        <a:cs typeface=""/>
+        <a:font script="Jpan" typeface="游ゴシック Light"/>
+        <a:font script="Hang" typeface="맑은 고딕"/>
+        <a:font script="Hans" typeface="等线 Light"/>
+        <a:font script="Hant" typeface="新細明體"/>
+        <a:font script="Arab" typeface="Times New Roman"/>
+        <a:font script="Hebr" typeface="Times New Roman"/>
+        <a:font script="Thai" typeface="Angsana New"/>
+        <a:font script="Ethi" typeface="Nyala"/>
+        <a:font script="Beng" typeface="Vrinda"/>
+        <a:font script="Gujr" typeface="Shruti"/>
+        <a:font script="Khmr" typeface="MoolBoran"/>
+        <a:font script="Knda" typeface="Tunga"/>
+        <a:font script="Guru" typeface="Raavi"/>
+        <a:font script="Cans" typeface="Euphemia"/>
+        <a:font script="Cher" typeface="Plantagenet Cherokee"/>
+        <a:font script="Yiii" typeface="Microsoft Yi Baiti"/>
+        <a:font script="Tibt" typeface="Microsoft Himalaya"/>
+        <a:font script="Thaa" typeface="MV Boli"/>
+        <a:font script="Deva" typeface="Mangal"/>
+        <a:font script="Telu" typeface="Gautami"/>
+        <a:font script="Taml" typeface="Latha"/>
+        <a:font script="Syrc" typeface="Estrangelo Edessa"/>
+        <a:font script="Orya" typeface="Kalinga"/>
+        <a:font script="Mlym" typeface="Kartika"/>
+        <a:font script="Laoo" typeface="DokChampa"/>
+        <a:font script="Sinh" typeface="Iskoola Pota"/>
+        <a:font script="Mong" typeface="Mongolian Baiti"/>
+        <a:font script="Viet" typeface="Times New Roman"/>
+        <a:font script="Uigh" typeface="Microsoft Uighur"/>
+        <a:font script="Geor" typeface="Sylfaen"/>
+        <a:font script="Armn" typeface="Arial"/>
+        <a:font script="Bugi" typeface="Leelawadee UI"/>
+        <a:font script="Bopo" typeface="Microsoft JhengHei"/>
+        <a:font script="Java" typeface="Javanese Text"/>
+        <a:font script="Lisu" typeface="Segoe UI"/>
+        <a:font script="Mymr" typeface="Myanmar Text"/>
+        <a:font script="Nkoo" typeface="Ebrima"/>
+        <a:font script="Olck" typeface="Nirmala UI"/>
+        <a:font script="Osma" typeface="Ebrima"/>
+        <a:font script="Phag" typeface="Phagspa"/>
+        <a:font script="Syrn" typeface="Estrangelo Edessa"/>
+        <a:font script="Syrj" typeface="Estrangelo Edessa"/>
+        <a:font script="Syre" typeface="Estrangelo Edessa"/>
+        <a:font script="Sora" typeface="Nirmala UI"/>
+        <a:font script="Tale" typeface="Microsoft Tai Le"/>
+        <a:font script="Talu" typeface="Microsoft New Tai Lue"/>
+        <a:font script="Tfng" typeface="Ebrima"/>
+      </a:majorFont>
+      <a:minorFont>
+        <a:latin typeface="Calibri" panose="020F0502020204030204"/>
+        <a:ea typeface=""/>
+        <a:cs typeface=""/>
+        <a:font script="Jpan" typeface="游ゴシック"/>
+        <a:font script="Hang" typeface="맑은 고딕"/>
+        <a:font script="Hans" typeface="等线"/>
+        <a:font script="Hant" typeface="新細明體"/>
+        <a:font script="Arab" typeface="Arial"/>
+        <a:font script="Hebr" typeface="Arial"/>
+        <a:font script="Thai" typeface="Cordia New"/>
+        <a:font script="Ethi" typeface="Nyala"/>
+        <a:font script="Beng" typeface="Vrinda"/>
+        <a:font script="Gujr" typeface="Shruti"/>
+        <a:font script="Khmr" typeface="DaunPenh"/>
+        <a:font script="Knda" typeface="Tunga"/>
+        <a:font script="Guru" typeface="Raavi"/>
+        <a:font script="Cans" typeface="Euphemia"/>
+        <a:font script="Cher" typeface="Plantagenet Cherokee"/>
+        <a:font script="Yiii" typeface="Microsoft Yi Baiti"/>
+        <a:font script="Tibt" typeface="Microsoft Himalaya"/>
+        <a:font script="Thaa" typeface="MV Boli"/>
+        <a:font script="Deva" typeface="Mangal"/>
+        <a:font script="Telu" typeface="Gautami"/>
+        <a:font script="Taml" typeface="Latha"/>
+        <a:font script="Syrc" typeface="Estrangelo Edessa"/>
+        <a:font script="Orya" typeface="Kalinga"/>
+        <a:font script="Mlym" typeface="Kartika"/>
+        <a:font script="Laoo" typeface="DokChampa"/>
+        <a:font script="Sinh" typeface="Iskoola Pota"/>
+        <a:font script="Mong" typeface="Mongolian Baiti"/>
+        <a:font script="Viet" typeface="Arial"/>
+        <a:font script="Uigh" typeface="Microsoft Uighur"/>
+        <a:font script="Geor" typeface="Sylfaen"/>
+        <a:font script="Armn" typeface="Arial"/>
+        <a:font script="Bugi" typeface="Leelawadee UI"/>
+        <a:font script="Bopo" typeface="Microsoft JhengHei"/>
+        <a:font script="Java" typeface="Javanese Text"/>
+        <a:font script="Lisu" typeface="Segoe UI"/>
+        <a:font script="Mymr" typeface="Myanmar Text"/>
+        <a:font script="Nkoo" typeface="Ebrima"/>
+        <a:font script="Olck" typeface="Nirmala UI"/>
+        <a:font script="Osma" typeface="Ebrima"/>
+        <a:font script="Phag" typeface="Phagspa"/>
+        <a:font script="Syrn" typeface="Estrangelo Edessa"/>
+        <a:font script="Syrj" typeface="Estrangelo Edessa"/>
+        <a:font script="Syre" typeface="Estrangelo Edessa"/>
+        <a:font script="Sora" typeface="Nirmala UI"/>
+        <a:font script="Tale" typeface="Microsoft Tai Le"/>
+        <a:font script="Talu" typeface="Microsoft New Tai Lue"/>
+        <a:font script="Tfng" typeface="Ebrima"/>
+      </a:minorFont>
+    </a:fontScheme>
+    <a:fmtScheme name="Office">
+      <a:fillStyleLst>
+        <a:solidFill>
+          <a:schemeClr val="phClr"/>
+        </a:solidFill>
+        <a:gradFill rotWithShape="1">
+          <a:gsLst>
+            <a:gs pos="0">
+              <a:schemeClr val="phClr">
+                <a:lumMod val="110000"/>
+                <a:satMod val="105000"/>
+                <a:tint val="67000"/>
+              </a:schemeClr>
+            </a:gs>
+            <a:gs pos="50000">
+              <a:schemeClr val="phClr">
+                <a:lumMod val="105000"/>
+                <a:satMod val="103000"/>
+                <a:tint val="73000"/>
+              </a:schemeClr>
+            </a:gs>
+            <a:gs pos="100000">
+              <a:schemeClr val="phClr">
+                <a:lumMod val="105000"/>
+                <a:satMod val="109000"/>
+                <a:tint val="81000"/>
+              </a:schemeClr>
+            </a:gs>
+          </a:gsLst>
+          <a:lin ang="5400000" scaled="0"/>
+        </a:gradFill>
+        <a:gradFill rotWithShape="1">
+          <a:gsLst>
+            <a:gs pos="0">
+              <a:schemeClr val="phClr">
+                <a:satMod val="103000"/>
+                <a:lumMod val="102000"/>
+                <a:tint val="94000"/>
+              </a:schemeClr>
+            </a:gs>
+            <a:gs pos="50000">
+              <a:schemeClr val="phClr">
+                <a:satMod val="110000"/>
+                <a:lumMod val="100000"/>
+                <a:shade val="100000"/>
+              </a:schemeClr>
+            </a:gs>
+            <a:gs pos="100000">
+              <a:schemeClr val="phClr">
+                <a:lumMod val="99000"/>
+                <a:satMod val="120000"/>
+                <a:shade val="78000"/>
+              </a:schemeClr>
+            </a:gs>
+          </a:gsLst>
+          <a:lin ang="5400000" scaled="0"/>
+        </a:gradFill>
+      </a:fillStyleLst>
+      <a:lnStyleLst>
+        <a:ln w="6350" cap="flat" cmpd="sng" algn="ctr">
+          <a:solidFill>
+            <a:schemeClr val="phClr"/>
+          </a:solidFill>
+          <a:prstDash val="solid"/>
+          <a:miter lim="800000"/>
+        </a:ln>
+        <a:ln w="12700" cap="flat" cmpd="sng" algn="ctr">
+          <a:solidFill>
+            <a:schemeClr val="phClr"/>
+          </a:solidFill>
+          <a:prstDash val="solid"/>
+          <a:miter lim="800000"/>
+        </a:ln>
+        <a:ln w="19050" cap="flat" cmpd="sng" algn="ctr">
+          <a:solidFill>
+            <a:schemeClr val="phClr"/>
+          </a:solidFill>
+          <a:prstDash val="solid"/>
+          <a:miter lim="800000"/>
+        </a:ln>
+      </a:lnStyleLst>
+      <a:effectStyleLst>
+        <a:effectStyle>
+          <a:effectLst/>
+        </a:effectStyle>
+        <a:effectStyle>
+          <a:effectLst/>
+        </a:effectStyle>
+        <a:effectStyle>
+          <a:effectLst>
+            <a:outerShdw blurRad="57150" dist="19050" dir="5400000" algn="ctr" rotWithShape="0">
+              <a:srgbClr val="000000">
+                <a:alpha val="63000"/>
+              </a:srgbClr>
+            </a:outerShdw>
+          </a:effectLst>
+        </a:effectStyle>
+      </a:effectStyleLst>
+      <a:bgFillStyleLst>
+        <a:solidFill>
+          <a:schemeClr val="phClr"/>
+        </a:solidFill>
+        <a:solidFill>
+          <a:schemeClr val="phClr">
+            <a:tint val="95000"/>
+            <a:satMod val="170000"/>
+          </a:schemeClr>
+        </a:solidFill>
+        <a:gradFill rotWithShape="1">
+          <a:gsLst>
+            <a:gs pos="0">
+              <a:schemeClr val="phClr">
+                <a:tint val="93000"/>
+                <a:satMod val="150000"/>
+                <a:shade val="98000"/>
+                <a:lumMod val="102000"/>
+              </a:schemeClr>
+            </a:gs>
+            <a:gs pos="50000">
+              <a:schemeClr val="phClr">
+                <a:tint val="98000"/>
+                <a:satMod val="130000"/>
+                <a:shade val="90000"/>
+                <a:lumMod val="103000"/>
+              </a:schemeClr>
+            </a:gs>
+            <a:gs pos="100000">
+              <a:schemeClr val="phClr">
+                <a:shade val="63000"/>
+                <a:satMod val="120000"/>
+              </a:schemeClr>
+            </a:gs>
+          </a:gsLst>
+          <a:lin ang="5400000" scaled="0"/>
+        </a:gradFill>
+      </a:bgFillStyleLst>
+    </a:fmtScheme>
+  </a:themeElements>
+  <a:objectDefaults/>
+  <a:extraClrSchemeLst/>
+  <a:extLst>
+    <a:ext uri="{05A4C25C-085E-4340-85A3-A5531E510DB2}">
+      <thm15:themeFamily xmlns:thm15="http://schemas.microsoft.com/office/thememl/2012/main" name="Office Theme" id="{62F939B6-93AF-4DB8-9C6B-D6C7DFDC589F}" vid="{4A3C46E8-61CC-4603-A589-7422A47A8E4A}"/>
+    </a:ext>
+  </a:extLst>
+</a:theme>
 </file>
</xml_diff>